<commit_message>
update wee01 and week2 labs and slides
</commit_message>
<xml_diff>
--- a/slides/week-02/Week02_Session1_Sequencing_Design_QC.pptx
+++ b/slides/week-02/Week02_Session1_Sequencing_Design_QC.pptx
@@ -3480,7 +3480,7 @@
               <a:buNone/>
             </a:pPr>
             <a:r>
-              <a:rPr lang="en-US" sz="1400" dirty="0">
+              <a:rPr lang="en-US" sz="1600" dirty="0">
                 <a:solidFill>
                   <a:srgbClr val="6B7280"/>
                 </a:solidFill>
@@ -3623,6 +3623,10 @@
             <a:prstDash val="solid"/>
           </a:ln>
         </p:spPr>
+        <p:txBody>
+          <a:bodyPr/>
+          <a:p/>
+        </p:txBody>
       </p:sp>
       <p:sp>
         <p:nvSpPr>
@@ -3649,7 +3653,7 @@
               <a:buNone/>
             </a:pPr>
             <a:r>
-              <a:rPr lang="en-US" sz="1450" b="1" dirty="0">
+              <a:rPr lang="en-US" sz="1650" b="1" dirty="0">
                 <a:solidFill>
                   <a:srgbClr val="205081"/>
                 </a:solidFill>
@@ -3691,7 +3695,7 @@
               <a:buNone/>
             </a:pPr>
             <a:r>
-              <a:rPr lang="en-US" sz="1300" dirty="0">
+              <a:rPr lang="en-US" sz="1650" dirty="0">
                 <a:solidFill>
                   <a:srgbClr val="1F2933"/>
                 </a:solidFill>
@@ -3699,7 +3703,7 @@
                 <a:ea typeface="Arial" pitchFamily="34" charset="-122"/>
                 <a:cs typeface="Arial" pitchFamily="34" charset="-120"/>
               </a:rPr>
-              <a:t>The Mouse ENCODE consortium compared gene expression across matched tissues in human and mouse — liver, heart, brain, and others.</a:t>
+              <a:t>Mouse ENCODE compared gene expression across matched tissues in human and mouse.</a:t>
             </a:r>
             <a:endParaRPr lang="en-US" sz="1300" dirty="0"/>
           </a:p>
@@ -3733,7 +3737,7 @@
               <a:buNone/>
             </a:pPr>
             <a:r>
-              <a:rPr lang="en-US" sz="1400" b="1" dirty="0">
+              <a:rPr lang="en-US" sz="1700" b="1" dirty="0">
                 <a:solidFill>
                   <a:srgbClr val="1F2933"/>
                 </a:solidFill>
@@ -3741,7 +3745,7 @@
                 <a:ea typeface="Arial" pitchFamily="34" charset="-122"/>
                 <a:cs typeface="Arial" pitchFamily="34" charset="-120"/>
               </a:rPr>
-              <a:t>They reported that samples clustered by species, not by tissue. Human liver grouped with human brain, rather than with mouse liver.</a:t>
+              <a:t>Samples clustered by species, not tissue. Human liver grouped with human brain, not mouse liver.</a:t>
             </a:r>
             <a:endParaRPr lang="en-US" sz="1400" dirty="0"/>
           </a:p>
@@ -3772,7 +3776,7 @@
               <a:buNone/>
             </a:pPr>
             <a:r>
-              <a:rPr lang="en-US" sz="1250" i="1" dirty="0">
+              <a:rPr lang="en-US" sz="1600" i="1" dirty="0">
                 <a:solidFill>
                   <a:srgbClr val="6B7280"/>
                 </a:solidFill>
@@ -3780,7 +3784,7 @@
                 <a:ea typeface="Arial" pitchFamily="34" charset="-122"/>
                 <a:cs typeface="Arial" pitchFamily="34" charset="-120"/>
               </a:rPr>
-              <a:t>Read literally: a human and a mouse liver are less alike than a human liver and a human brain.</a:t>
+              <a:t>Read literally: human and mouse liver are less alike than human liver and human brain.</a:t>
             </a:r>
             <a:endParaRPr lang="en-US" sz="1250" dirty="0"/>
           </a:p>
@@ -3812,6 +3816,10 @@
             <a:prstDash val="solid"/>
           </a:ln>
         </p:spPr>
+        <p:txBody>
+          <a:bodyPr/>
+          <a:p/>
+        </p:txBody>
       </p:sp>
       <p:sp>
         <p:nvSpPr>
@@ -3838,7 +3846,7 @@
               <a:buNone/>
             </a:pPr>
             <a:r>
-              <a:rPr lang="en-US" sz="1450" b="1" dirty="0">
+              <a:rPr lang="en-US" sz="1650" b="1" dirty="0">
                 <a:solidFill>
                   <a:srgbClr val="3172AE"/>
                 </a:solidFill>
@@ -3920,7 +3928,7 @@
               <a:buChar char="●"/>
             </a:pPr>
             <a:r>
-              <a:rPr lang="en-US" sz="1150" dirty="0">
+              <a:rPr lang="en-US" sz="1550" dirty="0">
                 <a:solidFill>
                   <a:srgbClr val="1F2933"/>
                 </a:solidFill>
@@ -3928,7 +3936,7 @@
                 <a:ea typeface="Arial" pitchFamily="34" charset="-122"/>
                 <a:cs typeface="Arial" pitchFamily="34" charset="-120"/>
               </a:rPr>
-              <a:t>It contradicts a century of comparative anatomy and development.</a:t>
+              <a:t>Contradicts a century of comparative anatomy.</a:t>
             </a:r>
             <a:endParaRPr lang="en-US" sz="1150" dirty="0"/>
           </a:p>
@@ -3941,7 +3949,7 @@
               <a:buChar char="●"/>
             </a:pPr>
             <a:r>
-              <a:rPr lang="en-US" sz="1150" dirty="0">
+              <a:rPr lang="en-US" sz="1550" dirty="0">
                 <a:solidFill>
                   <a:srgbClr val="1F2933"/>
                 </a:solidFill>
@@ -3949,7 +3957,7 @@
                 <a:ea typeface="Arial" pitchFamily="34" charset="-122"/>
                 <a:cs typeface="Arial" pitchFamily="34" charset="-120"/>
               </a:rPr>
-              <a:t>Conserved developmental pathways say the opposite.</a:t>
+              <a:t>Conserved developmental pathways say otherwise.</a:t>
             </a:r>
             <a:endParaRPr lang="en-US" sz="1150" dirty="0"/>
           </a:p>
@@ -3962,7 +3970,7 @@
               <a:buChar char="●"/>
             </a:pPr>
             <a:r>
-              <a:rPr lang="en-US" sz="1150" dirty="0">
+              <a:rPr lang="en-US" sz="1550" dirty="0">
                 <a:solidFill>
                   <a:srgbClr val="1F2933"/>
                 </a:solidFill>
@@ -3970,7 +3978,7 @@
                 <a:ea typeface="Arial" pitchFamily="34" charset="-122"/>
                 <a:cs typeface="Arial" pitchFamily="34" charset="-120"/>
               </a:rPr>
-              <a:t>It was published, peer-reviewed, and widely covered.</a:t>
+              <a:t>Published, peer-reviewed, widely covered.</a:t>
             </a:r>
             <a:endParaRPr lang="en-US" sz="1150" dirty="0"/>
           </a:p>
@@ -4001,7 +4009,7 @@
               <a:buNone/>
             </a:pPr>
             <a:r>
-              <a:rPr lang="en-US" sz="1400" b="1" dirty="0">
+              <a:rPr lang="en-US" sz="1600" b="1" dirty="0">
                 <a:solidFill>
                   <a:srgbClr val="205081"/>
                 </a:solidFill>
@@ -4144,6 +4152,10 @@
             <a:prstDash val="solid"/>
           </a:ln>
         </p:spPr>
+        <p:txBody>
+          <a:bodyPr/>
+          <a:p/>
+        </p:txBody>
       </p:sp>
       <p:sp>
         <p:nvSpPr>
@@ -4170,7 +4182,7 @@
               <a:buNone/>
             </a:pPr>
             <a:r>
-              <a:rPr lang="en-US" sz="1600" b="1" dirty="0">
+              <a:rPr lang="en-US" sz="1750" b="1" dirty="0">
                 <a:solidFill>
                   <a:srgbClr val="1F2933"/>
                 </a:solidFill>
@@ -4249,6 +4261,10 @@
             <a:prstDash val="solid"/>
           </a:ln>
         </p:spPr>
+        <p:txBody>
+          <a:bodyPr/>
+          <a:p/>
+        </p:txBody>
       </p:sp>
       <p:sp>
         <p:nvSpPr>
@@ -4274,6 +4290,10 @@
             <a:prstDash val="solid"/>
           </a:ln>
         </p:spPr>
+        <p:txBody>
+          <a:bodyPr/>
+          <a:p/>
+        </p:txBody>
       </p:sp>
       <p:sp>
         <p:nvSpPr>
@@ -4300,7 +4320,7 @@
               <a:buNone/>
             </a:pPr>
             <a:r>
-              <a:rPr lang="en-US" sz="1400" b="1" dirty="0">
+              <a:rPr lang="en-US" sz="1600" b="1" dirty="0">
                 <a:solidFill>
                   <a:srgbClr val="1F2933"/>
                 </a:solidFill>
@@ -4343,7 +4363,7 @@
               <a:buChar char="●"/>
             </a:pPr>
             <a:r>
-              <a:rPr lang="en-US" sz="1150" dirty="0">
+              <a:rPr lang="en-US" sz="1550" dirty="0">
                 <a:solidFill>
                   <a:srgbClr val="1F2933"/>
                 </a:solidFill>
@@ -4351,7 +4371,7 @@
                 <a:ea typeface="Arial" pitchFamily="34" charset="-122"/>
                 <a:cs typeface="Arial" pitchFamily="34" charset="-120"/>
               </a:rPr>
-              <a:t>Recovered batch identity from the read headers of the public FASTQ files.</a:t>
+              <a:t>Recovered batch identity from the public FASTQ headers.</a:t>
             </a:r>
             <a:endParaRPr lang="en-US" sz="1150" dirty="0"/>
           </a:p>
@@ -4364,7 +4384,7 @@
               <a:buChar char="●"/>
             </a:pPr>
             <a:r>
-              <a:rPr lang="en-US" sz="1150" dirty="0">
+              <a:rPr lang="en-US" sz="1550" dirty="0">
                 <a:solidFill>
                   <a:srgbClr val="1F2933"/>
                 </a:solidFill>
@@ -4385,7 +4405,7 @@
               <a:buChar char="●"/>
             </a:pPr>
             <a:r>
-              <a:rPr lang="en-US" sz="1150" dirty="0">
+              <a:rPr lang="en-US" sz="1550" dirty="0">
                 <a:solidFill>
                   <a:srgbClr val="1F2933"/>
                 </a:solidFill>
@@ -4425,6 +4445,10 @@
             <a:prstDash val="solid"/>
           </a:ln>
         </p:spPr>
+        <p:txBody>
+          <a:bodyPr/>
+          <a:p/>
+        </p:txBody>
       </p:sp>
       <p:sp>
         <p:nvSpPr>
@@ -4450,6 +4474,10 @@
             <a:prstDash val="solid"/>
           </a:ln>
         </p:spPr>
+        <p:txBody>
+          <a:bodyPr/>
+          <a:p/>
+        </p:txBody>
       </p:sp>
       <p:sp>
         <p:nvSpPr>
@@ -4476,7 +4504,7 @@
               <a:buNone/>
             </a:pPr>
             <a:r>
-              <a:rPr lang="en-US" sz="1400" b="1" dirty="0">
+              <a:rPr lang="en-US" sz="1600" b="1" dirty="0">
                 <a:solidFill>
                   <a:srgbClr val="1F2933"/>
                 </a:solidFill>
@@ -4519,7 +4547,7 @@
               <a:buChar char="●"/>
             </a:pPr>
             <a:r>
-              <a:rPr lang="en-US" sz="1150" dirty="0">
+              <a:rPr lang="en-US" sz="1550" dirty="0">
                 <a:solidFill>
                   <a:srgbClr val="1F2933"/>
                 </a:solidFill>
@@ -4527,7 +4555,7 @@
                 <a:ea typeface="Arial" pitchFamily="34" charset="-122"/>
                 <a:cs typeface="Arial" pitchFamily="34" charset="-120"/>
               </a:rPr>
-              <a:t>Samples clustered by tissue, as a century of biology says they should.</a:t>
+              <a:t>Samples clustered by tissue, as biology says they should.</a:t>
             </a:r>
             <a:endParaRPr lang="en-US" sz="1150" dirty="0"/>
           </a:p>
@@ -4540,7 +4568,7 @@
               <a:buChar char="●"/>
             </a:pPr>
             <a:r>
-              <a:rPr lang="en-US" sz="1150" dirty="0">
+              <a:rPr lang="en-US" sz="1550" dirty="0">
                 <a:solidFill>
                   <a:srgbClr val="1F2933"/>
                 </a:solidFill>
@@ -4548,7 +4576,7 @@
                 <a:ea typeface="Arial" pitchFamily="34" charset="-122"/>
                 <a:cs typeface="Arial" pitchFamily="34" charset="-120"/>
               </a:rPr>
-              <a:t>The species-clustering result did not survive.</a:t>
+              <a:t>The species result did not survive.</a:t>
             </a:r>
             <a:endParaRPr lang="en-US" sz="1150" dirty="0"/>
           </a:p>
@@ -4561,7 +4589,7 @@
               <a:buChar char="●"/>
             </a:pPr>
             <a:r>
-              <a:rPr lang="en-US" sz="1150" dirty="0">
+              <a:rPr lang="en-US" sz="1550" dirty="0">
                 <a:solidFill>
                   <a:srgbClr val="1F2933"/>
                 </a:solidFill>
@@ -4569,7 +4597,7 @@
                 <a:ea typeface="Arial" pitchFamily="34" charset="-122"/>
                 <a:cs typeface="Arial" pitchFamily="34" charset="-120"/>
               </a:rPr>
-              <a:t>The original data were fine. The assignment of samples to runs was not.</a:t>
+              <a:t>The data were fine. The assignment to runs was not.</a:t>
             </a:r>
             <a:endParaRPr lang="en-US" sz="1150" dirty="0"/>
           </a:p>
@@ -4601,6 +4629,10 @@
             <a:prstDash val="solid"/>
           </a:ln>
         </p:spPr>
+        <p:txBody>
+          <a:bodyPr/>
+          <a:p/>
+        </p:txBody>
       </p:sp>
       <p:sp>
         <p:nvSpPr>
@@ -4626,6 +4658,10 @@
             <a:prstDash val="solid"/>
           </a:ln>
         </p:spPr>
+        <p:txBody>
+          <a:bodyPr/>
+          <a:p/>
+        </p:txBody>
       </p:sp>
       <p:sp>
         <p:nvSpPr>
@@ -4652,7 +4688,7 @@
               <a:buNone/>
             </a:pPr>
             <a:r>
-              <a:rPr lang="en-US" sz="1400" b="1" dirty="0">
+              <a:rPr lang="en-US" sz="1600" b="1" dirty="0">
                 <a:solidFill>
                   <a:srgbClr val="1F2933"/>
                 </a:solidFill>
@@ -4695,7 +4731,7 @@
               <a:buChar char="●"/>
             </a:pPr>
             <a:r>
-              <a:rPr lang="en-US" sz="1150" dirty="0">
+              <a:rPr lang="en-US" sz="1550" dirty="0">
                 <a:solidFill>
                   <a:srgbClr val="1F2933"/>
                 </a:solidFill>
@@ -4716,7 +4752,7 @@
               <a:buChar char="●"/>
             </a:pPr>
             <a:r>
-              <a:rPr lang="en-US" sz="1150" dirty="0">
+              <a:rPr lang="en-US" sz="1550" dirty="0">
                 <a:solidFill>
                   <a:srgbClr val="1F2933"/>
                 </a:solidFill>
@@ -4737,7 +4773,7 @@
               <a:buChar char="●"/>
             </a:pPr>
             <a:r>
-              <a:rPr lang="en-US" sz="1150" dirty="0">
+              <a:rPr lang="en-US" sz="1550" dirty="0">
                 <a:solidFill>
                   <a:srgbClr val="1F2933"/>
                 </a:solidFill>
@@ -4745,7 +4781,7 @@
                 <a:ea typeface="Arial" pitchFamily="34" charset="-122"/>
                 <a:cs typeface="Arial" pitchFamily="34" charset="-120"/>
               </a:rPr>
-              <a:t>None of it fixable without re-sequencing.</a:t>
+              <a:t>Unfixable without re-sequencing.</a:t>
             </a:r>
             <a:endParaRPr lang="en-US" sz="1150" dirty="0"/>
           </a:p>
@@ -4776,7 +4812,7 @@
               <a:buNone/>
             </a:pPr>
             <a:r>
-              <a:rPr lang="en-US" sz="1350" b="1" dirty="0">
+              <a:rPr lang="en-US" sz="1700" b="1" dirty="0">
                 <a:solidFill>
                   <a:srgbClr val="205081"/>
                 </a:solidFill>
@@ -4784,7 +4820,7 @@
                 <a:ea typeface="Arial" pitchFamily="34" charset="-122"/>
                 <a:cs typeface="Arial" pitchFamily="34" charset="-120"/>
               </a:rPr>
-              <a:t>Hold on to one detail: the fix was only possible because the FASTQ headers still recorded flow cell and lane. We come back to that in fifteen minutes.</a:t>
+              <a:t>The fix worked only because the FASTQ headers still recorded flow cell and lane.</a:t>
             </a:r>
             <a:endParaRPr lang="en-US" sz="1350" dirty="0"/>
           </a:p>
@@ -4919,6 +4955,10 @@
             <a:prstDash val="solid"/>
           </a:ln>
         </p:spPr>
+        <p:txBody>
+          <a:bodyPr/>
+          <a:p/>
+        </p:txBody>
       </p:sp>
       <p:sp>
         <p:nvSpPr>
@@ -4948,7 +4988,7 @@
               <a:buNone/>
             </a:pPr>
             <a:r>
-              <a:rPr lang="en-US" sz="1400" dirty="0">
+              <a:rPr lang="en-US" sz="1600" dirty="0">
                 <a:solidFill>
                   <a:srgbClr val="1F2933"/>
                 </a:solidFill>
@@ -4988,6 +5028,10 @@
             <a:prstDash val="solid"/>
           </a:ln>
         </p:spPr>
+        <p:txBody>
+          <a:bodyPr/>
+          <a:p/>
+        </p:txBody>
       </p:sp>
       <p:sp>
         <p:nvSpPr>
@@ -5014,7 +5058,7 @@
               <a:buNone/>
             </a:pPr>
             <a:r>
-              <a:rPr lang="en-US" sz="1300" b="1" dirty="0">
+              <a:rPr lang="en-US" sz="1550" b="1" dirty="0">
                 <a:solidFill>
                   <a:srgbClr val="3172AE"/>
                 </a:solidFill>
@@ -5056,7 +5100,7 @@
               <a:buNone/>
             </a:pPr>
             <a:r>
-              <a:rPr lang="en-US" sz="1450" b="1" dirty="0">
+              <a:rPr lang="en-US" sz="1650" b="1" dirty="0">
                 <a:solidFill>
                   <a:srgbClr val="1F2933"/>
                 </a:solidFill>
@@ -5134,7 +5178,7 @@
               <a:buNone/>
             </a:pPr>
             <a:r>
-              <a:rPr lang="en-US" sz="1300" b="1" dirty="0">
+              <a:rPr lang="en-US" sz="1550" b="1" dirty="0">
                 <a:solidFill>
                   <a:srgbClr val="1F2933"/>
                 </a:solidFill>
@@ -5173,7 +5217,7 @@
               <a:buNone/>
             </a:pPr>
             <a:r>
-              <a:rPr lang="en-US" sz="950" dirty="0">
+              <a:rPr lang="en-US" sz="1150" dirty="0">
                 <a:solidFill>
                   <a:srgbClr val="6B7280"/>
                 </a:solidFill>
@@ -5212,7 +5256,7 @@
               <a:buNone/>
             </a:pPr>
             <a:r>
-              <a:rPr lang="en-US" sz="950" dirty="0">
+              <a:rPr lang="en-US" sz="1150" dirty="0">
                 <a:solidFill>
                   <a:srgbClr val="6B7280"/>
                 </a:solidFill>
@@ -5251,7 +5295,7 @@
               <a:buNone/>
             </a:pPr>
             <a:r>
-              <a:rPr lang="en-US" sz="1000" dirty="0">
+              <a:rPr lang="en-US" sz="1200" dirty="0">
                 <a:solidFill>
                   <a:srgbClr val="6B7280"/>
                 </a:solidFill>
@@ -5291,6 +5335,10 @@
             <a:prstDash val="solid"/>
           </a:ln>
         </p:spPr>
+        <p:txBody>
+          <a:bodyPr/>
+          <a:p/>
+        </p:txBody>
       </p:sp>
       <p:sp>
         <p:nvSpPr>
@@ -5317,7 +5365,7 @@
               <a:buNone/>
             </a:pPr>
             <a:r>
-              <a:rPr lang="en-US" sz="1000" b="1" dirty="0">
+              <a:rPr lang="en-US" sz="1200" b="1" dirty="0">
                 <a:solidFill>
                   <a:srgbClr val="FFFFFF"/>
                 </a:solidFill>
@@ -5357,6 +5405,10 @@
             <a:prstDash val="solid"/>
           </a:ln>
         </p:spPr>
+        <p:txBody>
+          <a:bodyPr/>
+          <a:p/>
+        </p:txBody>
       </p:sp>
       <p:sp>
         <p:nvSpPr>
@@ -5383,7 +5435,7 @@
               <a:buNone/>
             </a:pPr>
             <a:r>
-              <a:rPr lang="en-US" sz="1000" b="1" dirty="0">
+              <a:rPr lang="en-US" sz="1200" b="1" dirty="0">
                 <a:solidFill>
                   <a:srgbClr val="9AA5B1"/>
                 </a:solidFill>
@@ -5422,7 +5474,7 @@
               <a:buNone/>
             </a:pPr>
             <a:r>
-              <a:rPr lang="en-US" sz="1000" dirty="0">
+              <a:rPr lang="en-US" sz="1200" dirty="0">
                 <a:solidFill>
                   <a:srgbClr val="6B7280"/>
                 </a:solidFill>
@@ -5462,6 +5514,10 @@
             <a:prstDash val="solid"/>
           </a:ln>
         </p:spPr>
+        <p:txBody>
+          <a:bodyPr/>
+          <a:p/>
+        </p:txBody>
       </p:sp>
       <p:sp>
         <p:nvSpPr>
@@ -5488,7 +5544,7 @@
               <a:buNone/>
             </a:pPr>
             <a:r>
-              <a:rPr lang="en-US" sz="1000" b="1" dirty="0">
+              <a:rPr lang="en-US" sz="1200" b="1" dirty="0">
                 <a:solidFill>
                   <a:srgbClr val="9AA5B1"/>
                 </a:solidFill>
@@ -5528,6 +5584,10 @@
             <a:prstDash val="solid"/>
           </a:ln>
         </p:spPr>
+        <p:txBody>
+          <a:bodyPr/>
+          <a:p/>
+        </p:txBody>
       </p:sp>
       <p:sp>
         <p:nvSpPr>
@@ -5554,7 +5614,7 @@
               <a:buNone/>
             </a:pPr>
             <a:r>
-              <a:rPr lang="en-US" sz="1000" b="1" dirty="0">
+              <a:rPr lang="en-US" sz="1200" b="1" dirty="0">
                 <a:solidFill>
                   <a:srgbClr val="FFFFFF"/>
                 </a:solidFill>
@@ -5593,7 +5653,7 @@
               <a:buNone/>
             </a:pPr>
             <a:r>
-              <a:rPr lang="en-US" sz="1100" b="1" dirty="0">
+              <a:rPr lang="en-US" sz="1350" b="1" dirty="0">
                 <a:solidFill>
                   <a:srgbClr val="B8860B"/>
                 </a:solidFill>
@@ -5632,7 +5692,7 @@
               <a:buNone/>
             </a:pPr>
             <a:r>
-              <a:rPr lang="en-US" sz="1300" b="1" dirty="0">
+              <a:rPr lang="en-US" sz="1550" b="1" dirty="0">
                 <a:solidFill>
                   <a:srgbClr val="1F2933"/>
                 </a:solidFill>
@@ -5671,7 +5731,7 @@
               <a:buNone/>
             </a:pPr>
             <a:r>
-              <a:rPr lang="en-US" sz="950" dirty="0">
+              <a:rPr lang="en-US" sz="1150" dirty="0">
                 <a:solidFill>
                   <a:srgbClr val="6B7280"/>
                 </a:solidFill>
@@ -5710,7 +5770,7 @@
               <a:buNone/>
             </a:pPr>
             <a:r>
-              <a:rPr lang="en-US" sz="950" dirty="0">
+              <a:rPr lang="en-US" sz="1150" dirty="0">
                 <a:solidFill>
                   <a:srgbClr val="6B7280"/>
                 </a:solidFill>
@@ -5749,7 +5809,7 @@
               <a:buNone/>
             </a:pPr>
             <a:r>
-              <a:rPr lang="en-US" sz="1000" dirty="0">
+              <a:rPr lang="en-US" sz="1200" dirty="0">
                 <a:solidFill>
                   <a:srgbClr val="6B7280"/>
                 </a:solidFill>
@@ -5789,6 +5849,10 @@
             <a:prstDash val="solid"/>
           </a:ln>
         </p:spPr>
+        <p:txBody>
+          <a:bodyPr/>
+          <a:p/>
+        </p:txBody>
       </p:sp>
       <p:sp>
         <p:nvSpPr>
@@ -5815,7 +5879,7 @@
               <a:buNone/>
             </a:pPr>
             <a:r>
-              <a:rPr lang="en-US" sz="1000" b="1" dirty="0">
+              <a:rPr lang="en-US" sz="1200" b="1" dirty="0">
                 <a:solidFill>
                   <a:srgbClr val="FFFFFF"/>
                 </a:solidFill>
@@ -5855,6 +5919,10 @@
             <a:prstDash val="solid"/>
           </a:ln>
         </p:spPr>
+        <p:txBody>
+          <a:bodyPr/>
+          <a:p/>
+        </p:txBody>
       </p:sp>
       <p:sp>
         <p:nvSpPr>
@@ -5881,7 +5949,7 @@
               <a:buNone/>
             </a:pPr>
             <a:r>
-              <a:rPr lang="en-US" sz="1000" b="1" dirty="0">
+              <a:rPr lang="en-US" sz="1200" b="1" dirty="0">
                 <a:solidFill>
                   <a:srgbClr val="FFFFFF"/>
                 </a:solidFill>
@@ -5920,7 +5988,7 @@
               <a:buNone/>
             </a:pPr>
             <a:r>
-              <a:rPr lang="en-US" sz="1000" dirty="0">
+              <a:rPr lang="en-US" sz="1200" dirty="0">
                 <a:solidFill>
                   <a:srgbClr val="6B7280"/>
                 </a:solidFill>
@@ -5960,6 +6028,10 @@
             <a:prstDash val="solid"/>
           </a:ln>
         </p:spPr>
+        <p:txBody>
+          <a:bodyPr/>
+          <a:p/>
+        </p:txBody>
       </p:sp>
       <p:sp>
         <p:nvSpPr>
@@ -5986,7 +6058,7 @@
               <a:buNone/>
             </a:pPr>
             <a:r>
-              <a:rPr lang="en-US" sz="1000" b="1" dirty="0">
+              <a:rPr lang="en-US" sz="1200" b="1" dirty="0">
                 <a:solidFill>
                   <a:srgbClr val="FFFFFF"/>
                 </a:solidFill>
@@ -6026,6 +6098,10 @@
             <a:prstDash val="solid"/>
           </a:ln>
         </p:spPr>
+        <p:txBody>
+          <a:bodyPr/>
+          <a:p/>
+        </p:txBody>
       </p:sp>
       <p:sp>
         <p:nvSpPr>
@@ -6052,7 +6128,7 @@
               <a:buNone/>
             </a:pPr>
             <a:r>
-              <a:rPr lang="en-US" sz="1000" b="1" dirty="0">
+              <a:rPr lang="en-US" sz="1200" b="1" dirty="0">
                 <a:solidFill>
                   <a:srgbClr val="FFFFFF"/>
                 </a:solidFill>
@@ -6091,7 +6167,7 @@
               <a:buNone/>
             </a:pPr>
             <a:r>
-              <a:rPr lang="en-US" sz="1100" b="1" dirty="0">
+              <a:rPr lang="en-US" sz="1350" b="1" dirty="0">
                 <a:solidFill>
                   <a:srgbClr val="205081"/>
                 </a:solidFill>
@@ -6131,6 +6207,10 @@
             <a:prstDash val="solid"/>
           </a:ln>
         </p:spPr>
+        <p:txBody>
+          <a:bodyPr/>
+          <a:p/>
+        </p:txBody>
       </p:sp>
       <p:sp>
         <p:nvSpPr>
@@ -6160,7 +6240,7 @@
               <a:buNone/>
             </a:pPr>
             <a:r>
-              <a:rPr lang="en-US" sz="1300" dirty="0">
+              <a:rPr lang="en-US" sz="1650" dirty="0">
                 <a:solidFill>
                   <a:srgbClr val="1F2933"/>
                 </a:solidFill>
@@ -6168,7 +6248,7 @@
                 <a:ea typeface="Arial" pitchFamily="34" charset="-122"/>
                 <a:cs typeface="Arial" pitchFamily="34" charset="-120"/>
               </a:rPr>
-              <a:t>A balanced design does not remove the batch effect. It makes the batch effect estimable — which is all you need, because then it goes in the model as a covariate (Week 6).</a:t>
+              <a:t>A balanced design does not remove the batch effect. It makes it estimable, which is all you need — it then goes in the model as a covariate.</a:t>
             </a:r>
             <a:endParaRPr lang="en-US" sz="1300" dirty="0"/>
           </a:p>
@@ -7329,6 +7409,10 @@
             <a:prstDash val="solid"/>
           </a:ln>
         </p:spPr>
+        <p:txBody>
+          <a:bodyPr/>
+          <a:p/>
+        </p:txBody>
       </p:sp>
       <p:sp>
         <p:nvSpPr>
@@ -7355,7 +7439,7 @@
               <a:buNone/>
             </a:pPr>
             <a:r>
-              <a:rPr lang="en-US" sz="1600" b="1" dirty="0">
+              <a:rPr lang="en-US" sz="1750" b="1" dirty="0">
                 <a:solidFill>
                   <a:srgbClr val="1F2933"/>
                 </a:solidFill>
@@ -7397,7 +7481,7 @@
               <a:buNone/>
             </a:pPr>
             <a:r>
-              <a:rPr lang="en-US" sz="1250" dirty="0">
+              <a:rPr lang="en-US" sz="1700" dirty="0">
                 <a:solidFill>
                   <a:srgbClr val="1F2933"/>
                 </a:solidFill>
@@ -7405,7 +7489,7 @@
                 <a:ea typeface="Arial" pitchFamily="34" charset="-122"/>
                 <a:cs typeface="Arial" pitchFamily="34" charset="-120"/>
               </a:rPr>
-              <a:t>So is one patient sampled three times on the same day, and one cell line split into three flasks an hour before treatment. Each of those is a perfectly good technical replicate and tells you nothing about whether your result generalises. Published papers make this mistake regularly — look for it in the dataset you pick for your homework.</a:t>
+              <a:t>So is one patient sampled three times in a day, or one culture split into three flasks before treatment. Fine technical replicates; they say nothing about whether the result generalises.</a:t>
             </a:r>
             <a:endParaRPr lang="en-US" sz="1250" dirty="0"/>
           </a:p>
@@ -7539,7 +7623,7 @@
               <a:buNone/>
             </a:pPr>
             <a:r>
-              <a:rPr lang="en-US" sz="1400" dirty="0">
+              <a:rPr lang="en-US" sz="1600" dirty="0">
                 <a:solidFill>
                   <a:srgbClr val="1F2933"/>
                 </a:solidFill>
@@ -7579,6 +7663,10 @@
             <a:prstDash val="solid"/>
           </a:ln>
         </p:spPr>
+        <p:txBody>
+          <a:bodyPr/>
+          <a:p/>
+        </p:txBody>
       </p:sp>
       <p:sp>
         <p:nvSpPr>
@@ -7644,7 +7732,7 @@
               <a:buNone/>
             </a:pPr>
             <a:r>
-              <a:rPr lang="en-US" sz="1250" dirty="0">
+              <a:rPr lang="en-US" sz="1500" dirty="0">
                 <a:solidFill>
                   <a:srgbClr val="6B7280"/>
                 </a:solidFill>
@@ -7686,7 +7774,7 @@
               <a:buNone/>
             </a:pPr>
             <a:r>
-              <a:rPr lang="en-US" sz="1150" dirty="0">
+              <a:rPr lang="en-US" sz="1400" dirty="0">
                 <a:solidFill>
                   <a:srgbClr val="1F2933"/>
                 </a:solidFill>
@@ -7706,7 +7794,7 @@
               <a:buNone/>
             </a:pPr>
             <a:r>
-              <a:rPr lang="en-US" sz="1150" dirty="0">
+              <a:rPr lang="en-US" sz="1400" dirty="0">
                 <a:solidFill>
                   <a:srgbClr val="1F2933"/>
                 </a:solidFill>
@@ -7746,6 +7834,10 @@
             <a:prstDash val="solid"/>
           </a:ln>
         </p:spPr>
+        <p:txBody>
+          <a:bodyPr/>
+          <a:p/>
+        </p:txBody>
       </p:sp>
       <p:sp>
         <p:nvSpPr>
@@ -7811,7 +7903,7 @@
               <a:buNone/>
             </a:pPr>
             <a:r>
-              <a:rPr lang="en-US" sz="1250" dirty="0">
+              <a:rPr lang="en-US" sz="1500" dirty="0">
                 <a:solidFill>
                   <a:srgbClr val="6B7280"/>
                 </a:solidFill>
@@ -7853,7 +7945,7 @@
               <a:buNone/>
             </a:pPr>
             <a:r>
-              <a:rPr lang="en-US" sz="1150" dirty="0">
+              <a:rPr lang="en-US" sz="1400" dirty="0">
                 <a:solidFill>
                   <a:srgbClr val="1F2933"/>
                 </a:solidFill>
@@ -7873,7 +7965,7 @@
               <a:buNone/>
             </a:pPr>
             <a:r>
-              <a:rPr lang="en-US" sz="1150" dirty="0">
+              <a:rPr lang="en-US" sz="1400" dirty="0">
                 <a:solidFill>
                   <a:srgbClr val="1F2933"/>
                 </a:solidFill>
@@ -7913,6 +8005,10 @@
             <a:prstDash val="solid"/>
           </a:ln>
         </p:spPr>
+        <p:txBody>
+          <a:bodyPr/>
+          <a:p/>
+        </p:txBody>
       </p:sp>
       <p:sp>
         <p:nvSpPr>
@@ -7978,7 +8074,7 @@
               <a:buNone/>
             </a:pPr>
             <a:r>
-              <a:rPr lang="en-US" sz="1250" dirty="0">
+              <a:rPr lang="en-US" sz="1500" dirty="0">
                 <a:solidFill>
                   <a:srgbClr val="6B7280"/>
                 </a:solidFill>
@@ -8020,7 +8116,7 @@
               <a:buNone/>
             </a:pPr>
             <a:r>
-              <a:rPr lang="en-US" sz="1150" dirty="0">
+              <a:rPr lang="en-US" sz="1400" dirty="0">
                 <a:solidFill>
                   <a:srgbClr val="1F2933"/>
                 </a:solidFill>
@@ -8040,7 +8136,7 @@
               <a:buNone/>
             </a:pPr>
             <a:r>
-              <a:rPr lang="en-US" sz="1150" dirty="0">
+              <a:rPr lang="en-US" sz="1400" dirty="0">
                 <a:solidFill>
                   <a:srgbClr val="1F2933"/>
                 </a:solidFill>
@@ -8080,6 +8176,10 @@
             <a:prstDash val="solid"/>
           </a:ln>
         </p:spPr>
+        <p:txBody>
+          <a:bodyPr/>
+          <a:p/>
+        </p:txBody>
       </p:sp>
       <p:sp>
         <p:nvSpPr>
@@ -8106,7 +8206,7 @@
               <a:buNone/>
             </a:pPr>
             <a:r>
-              <a:rPr lang="en-US" sz="1300" b="1" dirty="0">
+              <a:rPr lang="en-US" sz="1550" b="1" dirty="0">
                 <a:solidFill>
                   <a:srgbClr val="3172AE"/>
                 </a:solidFill>
@@ -8188,6 +8288,10 @@
             <a:prstDash val="solid"/>
           </a:ln>
         </p:spPr>
+        <p:txBody>
+          <a:bodyPr/>
+          <a:p/>
+        </p:txBody>
       </p:sp>
       <p:sp>
         <p:nvSpPr>
@@ -8214,7 +8318,7 @@
               <a:buNone/>
             </a:pPr>
             <a:r>
-              <a:rPr lang="en-US" sz="1500" b="1" dirty="0">
+              <a:rPr lang="en-US" sz="1700" b="1" dirty="0">
                 <a:solidFill>
                   <a:srgbClr val="1F2933"/>
                 </a:solidFill>
@@ -8256,7 +8360,7 @@
               <a:buNone/>
             </a:pPr>
             <a:r>
-              <a:rPr lang="en-US" sz="1250" dirty="0">
+              <a:rPr lang="en-US" sz="1650" dirty="0">
                 <a:solidFill>
                   <a:srgbClr val="6B7280"/>
                 </a:solidFill>
@@ -8264,7 +8368,7 @@
                 <a:ea typeface="Arial" pitchFamily="34" charset="-122"/>
                 <a:cs typeface="Arial" pitchFamily="34" charset="-120"/>
               </a:rPr>
-              <a:t>DE tools like DESeq2 do better than this by sharing dispersion information across thousands of genes — that is genuinely clever and genuinely helps. It does not manufacture replication. A design that cannot detect an effect still cannot detect it.</a:t>
+              <a:t>DESeq2 shares dispersion across thousands of genes, which is clever and genuinely helps. It does not manufacture replication.</a:t>
             </a:r>
             <a:endParaRPr lang="en-US" sz="1250" dirty="0"/>
           </a:p>
@@ -8295,7 +8399,7 @@
               <a:buNone/>
             </a:pPr>
             <a:r>
-              <a:rPr lang="en-US" sz="950" i="1" dirty="0">
+              <a:rPr lang="en-US" sz="1150" i="1" dirty="0">
                 <a:solidFill>
                   <a:srgbClr val="9AA5B1"/>
                 </a:solidFill>
@@ -8438,6 +8542,10 @@
             <a:prstDash val="solid"/>
           </a:ln>
         </p:spPr>
+        <p:txBody>
+          <a:bodyPr/>
+          <a:p/>
+        </p:txBody>
       </p:sp>
       <p:sp>
         <p:nvSpPr>
@@ -8464,7 +8572,7 @@
               <a:buNone/>
             </a:pPr>
             <a:r>
-              <a:rPr lang="en-US" sz="1050" b="1" spc="120" kern="0" dirty="0">
+              <a:rPr lang="en-US" sz="1250" b="1" spc="120" kern="0" dirty="0">
                 <a:solidFill>
                   <a:srgbClr val="2E7D32"/>
                 </a:solidFill>
@@ -8506,7 +8614,7 @@
               <a:buNone/>
             </a:pPr>
             <a:r>
-              <a:rPr lang="en-US" sz="1550" b="1" dirty="0">
+              <a:rPr lang="en-US" sz="1700" b="1" dirty="0">
                 <a:solidFill>
                   <a:srgbClr val="1F2933"/>
                 </a:solidFill>
@@ -8548,7 +8656,7 @@
               <a:buNone/>
             </a:pPr>
             <a:r>
-              <a:rPr lang="en-US" sz="1150" dirty="0">
+              <a:rPr lang="en-US" sz="1400" dirty="0">
                 <a:solidFill>
                   <a:srgbClr val="1F2933"/>
                 </a:solidFill>
@@ -8584,6 +8692,10 @@
             <a:prstDash val="solid"/>
           </a:ln>
         </p:spPr>
+        <p:txBody>
+          <a:bodyPr/>
+          <a:p/>
+        </p:txBody>
       </p:sp>
       <p:sp>
         <p:nvSpPr>
@@ -8613,7 +8725,7 @@
               <a:buNone/>
             </a:pPr>
             <a:r>
-              <a:rPr lang="en-US" sz="1150" dirty="0">
+              <a:rPr lang="en-US" sz="1550" dirty="0">
                 <a:solidFill>
                   <a:srgbClr val="6B7280"/>
                 </a:solidFill>
@@ -8621,7 +8733,7 @@
                 <a:ea typeface="Arial" pitchFamily="34" charset="-122"/>
                 <a:cs typeface="Arial" pitchFamily="34" charset="-120"/>
               </a:rPr>
-              <a:t>Put it in the model as a covariate. This is the design formula in Week 6. Problem solved, honestly and visibly.</a:t>
+              <a:t>Put it in the model as a covariate. Solved, honestly and visibly.</a:t>
             </a:r>
             <a:endParaRPr lang="en-US" sz="1150" dirty="0"/>
           </a:p>
@@ -8653,6 +8765,10 @@
             <a:prstDash val="solid"/>
           </a:ln>
         </p:spPr>
+        <p:txBody>
+          <a:bodyPr/>
+          <a:p/>
+        </p:txBody>
       </p:sp>
       <p:sp>
         <p:nvSpPr>
@@ -8679,7 +8795,7 @@
               <a:buNone/>
             </a:pPr>
             <a:r>
-              <a:rPr lang="en-US" sz="1050" b="1" spc="120" kern="0" dirty="0">
+              <a:rPr lang="en-US" sz="1250" b="1" spc="120" kern="0" dirty="0">
                 <a:solidFill>
                   <a:srgbClr val="B8860B"/>
                 </a:solidFill>
@@ -8721,7 +8837,7 @@
               <a:buNone/>
             </a:pPr>
             <a:r>
-              <a:rPr lang="en-US" sz="1550" b="1" dirty="0">
+              <a:rPr lang="en-US" sz="1700" b="1" dirty="0">
                 <a:solidFill>
                   <a:srgbClr val="1F2933"/>
                 </a:solidFill>
@@ -8763,7 +8879,7 @@
               <a:buNone/>
             </a:pPr>
             <a:r>
-              <a:rPr lang="en-US" sz="1150" dirty="0">
+              <a:rPr lang="en-US" sz="1400" dirty="0">
                 <a:solidFill>
                   <a:srgbClr val="1F2933"/>
                 </a:solidFill>
@@ -8799,6 +8915,10 @@
             <a:prstDash val="solid"/>
           </a:ln>
         </p:spPr>
+        <p:txBody>
+          <a:bodyPr/>
+          <a:p/>
+        </p:txBody>
       </p:sp>
       <p:sp>
         <p:nvSpPr>
@@ -8828,7 +8948,7 @@
               <a:buNone/>
             </a:pPr>
             <a:r>
-              <a:rPr lang="en-US" sz="1150" dirty="0">
+              <a:rPr lang="en-US" sz="1550" dirty="0">
                 <a:solidFill>
                   <a:srgbClr val="6B7280"/>
                 </a:solidFill>
@@ -8836,7 +8956,7 @@
                 <a:ea typeface="Arial" pitchFamily="34" charset="-122"/>
                 <a:cs typeface="Arial" pitchFamily="34" charset="-120"/>
               </a:rPr>
-              <a:t>Nothing to do analytically. You can detect it, name it, and report it as a limitation — that is the whole of your options.</a:t>
+              <a:t>Nothing to do analytically. Detect it, name it, report it as a limitation.</a:t>
             </a:r>
             <a:endParaRPr lang="en-US" sz="1150" dirty="0"/>
           </a:p>
@@ -8868,6 +8988,10 @@
             <a:prstDash val="solid"/>
           </a:ln>
         </p:spPr>
+        <p:txBody>
+          <a:bodyPr/>
+          <a:p/>
+        </p:txBody>
       </p:sp>
       <p:sp>
         <p:nvSpPr>
@@ -8894,7 +9018,7 @@
               <a:buNone/>
             </a:pPr>
             <a:r>
-              <a:rPr lang="en-US" sz="1050" b="1" spc="120" kern="0" dirty="0">
+              <a:rPr lang="en-US" sz="1250" b="1" spc="120" kern="0" dirty="0">
                 <a:solidFill>
                   <a:srgbClr val="C0392B"/>
                 </a:solidFill>
@@ -8936,7 +9060,7 @@
               <a:buNone/>
             </a:pPr>
             <a:r>
-              <a:rPr lang="en-US" sz="1550" b="1" dirty="0">
+              <a:rPr lang="en-US" sz="1700" b="1" dirty="0">
                 <a:solidFill>
                   <a:srgbClr val="1F2933"/>
                 </a:solidFill>
@@ -8978,7 +9102,7 @@
               <a:buNone/>
             </a:pPr>
             <a:r>
-              <a:rPr lang="en-US" sz="1150" dirty="0">
+              <a:rPr lang="en-US" sz="1400" dirty="0">
                 <a:solidFill>
                   <a:srgbClr val="1F2933"/>
                 </a:solidFill>
@@ -9014,6 +9138,10 @@
             <a:prstDash val="solid"/>
           </a:ln>
         </p:spPr>
+        <p:txBody>
+          <a:bodyPr/>
+          <a:p/>
+        </p:txBody>
       </p:sp>
       <p:sp>
         <p:nvSpPr>
@@ -9043,7 +9171,7 @@
               <a:buNone/>
             </a:pPr>
             <a:r>
-              <a:rPr lang="en-US" sz="1150" dirty="0">
+              <a:rPr lang="en-US" sz="1550" dirty="0">
                 <a:solidFill>
                   <a:srgbClr val="6B7280"/>
                 </a:solidFill>
@@ -9051,7 +9179,7 @@
                 <a:ea typeface="Arial" pitchFamily="34" charset="-122"/>
                 <a:cs typeface="Arial" pitchFamily="34" charset="-120"/>
               </a:rPr>
-              <a:t>You cannot check for it, correct it, or even know it happened. This is the most common tier and the least discussed.</a:t>
+              <a:t>You cannot check for it, correct it, or know it happened. The most common tier, and the least discussed.</a:t>
             </a:r>
             <a:endParaRPr lang="en-US" sz="1150" dirty="0"/>
           </a:p>
@@ -9083,6 +9211,10 @@
             <a:prstDash val="solid"/>
           </a:ln>
         </p:spPr>
+        <p:txBody>
+          <a:bodyPr/>
+          <a:p/>
+        </p:txBody>
       </p:sp>
       <p:sp>
         <p:nvSpPr>
@@ -9109,7 +9241,7 @@
               <a:buNone/>
             </a:pPr>
             <a:r>
-              <a:rPr lang="en-US" sz="1300" b="1" dirty="0">
+              <a:rPr lang="en-US" sz="1700" b="1" dirty="0">
                 <a:solidFill>
                   <a:srgbClr val="3172AE"/>
                 </a:solidFill>
@@ -9117,7 +9249,7 @@
                 <a:ea typeface="Arial" pitchFamily="34" charset="-122"/>
                 <a:cs typeface="Arial" pitchFamily="34" charset="-120"/>
               </a:rPr>
-              <a:t>The only defence against Tier 3 is a habit: record everything, at the time, in the sample sheet. It costs nothing and it is the difference between a limitation and a mystery.</a:t>
+              <a:t>The only defence against Tier 3 is a habit: record everything, at the time, in the sample sheet.</a:t>
             </a:r>
             <a:endParaRPr lang="en-US" sz="1300" dirty="0"/>
           </a:p>
@@ -9291,6 +9423,10 @@
             <a:prstDash val="solid"/>
           </a:ln>
         </p:spPr>
+        <p:txBody>
+          <a:bodyPr/>
+          <a:p/>
+        </p:txBody>
       </p:sp>
       <p:sp>
         <p:nvSpPr>
@@ -9317,7 +9453,7 @@
               <a:buNone/>
             </a:pPr>
             <a:r>
-              <a:rPr lang="en-US" sz="1300" b="1" dirty="0">
+              <a:rPr lang="en-US" sz="1550" b="1" dirty="0">
                 <a:solidFill>
                   <a:srgbClr val="4A5411"/>
                 </a:solidFill>
@@ -9357,6 +9493,10 @@
             <a:prstDash val="solid"/>
           </a:ln>
         </p:spPr>
+        <p:txBody>
+          <a:bodyPr/>
+          <a:p/>
+        </p:txBody>
       </p:sp>
       <p:sp>
         <p:nvSpPr>
@@ -9383,7 +9523,7 @@
               <a:buNone/>
             </a:pPr>
             <a:r>
-              <a:rPr lang="en-US" sz="1300" b="1" dirty="0">
+              <a:rPr lang="en-US" sz="1550" b="1" dirty="0">
                 <a:solidFill>
                   <a:srgbClr val="FFFFFF"/>
                 </a:solidFill>
@@ -9423,6 +9563,10 @@
             <a:prstDash val="solid"/>
           </a:ln>
         </p:spPr>
+        <p:txBody>
+          <a:bodyPr/>
+          <a:p/>
+        </p:txBody>
       </p:sp>
       <p:sp>
         <p:nvSpPr>
@@ -9449,7 +9593,7 @@
               <a:buNone/>
             </a:pPr>
             <a:r>
-              <a:rPr lang="en-US" sz="1300" b="1" dirty="0">
+              <a:rPr lang="en-US" sz="1550" b="1" dirty="0">
                 <a:solidFill>
                   <a:srgbClr val="FFFFFF"/>
                 </a:solidFill>
@@ -9489,6 +9633,10 @@
             <a:prstDash val="solid"/>
           </a:ln>
         </p:spPr>
+        <p:txBody>
+          <a:bodyPr/>
+          <a:p/>
+        </p:txBody>
       </p:sp>
       <p:sp>
         <p:nvSpPr>
@@ -9515,7 +9663,7 @@
               <a:buNone/>
             </a:pPr>
             <a:r>
-              <a:rPr lang="en-US" sz="1300" b="1" dirty="0">
+              <a:rPr lang="en-US" sz="1550" b="1" dirty="0">
                 <a:solidFill>
                   <a:srgbClr val="4A5411"/>
                 </a:solidFill>
@@ -9555,6 +9703,10 @@
             <a:prstDash val="solid"/>
           </a:ln>
         </p:spPr>
+        <p:txBody>
+          <a:bodyPr/>
+          <a:p/>
+        </p:txBody>
       </p:sp>
       <p:sp>
         <p:nvSpPr>
@@ -9581,7 +9733,7 @@
               <a:buNone/>
             </a:pPr>
             <a:r>
-              <a:rPr lang="en-US" sz="1300" b="1" dirty="0">
+              <a:rPr lang="en-US" sz="1550" b="1" dirty="0">
                 <a:solidFill>
                   <a:srgbClr val="FFFFFF"/>
                 </a:solidFill>
@@ -9621,6 +9773,10 @@
             <a:prstDash val="solid"/>
           </a:ln>
         </p:spPr>
+        <p:txBody>
+          <a:bodyPr/>
+          <a:p/>
+        </p:txBody>
       </p:sp>
       <p:sp>
         <p:nvSpPr>
@@ -9647,7 +9803,7 @@
               <a:buNone/>
             </a:pPr>
             <a:r>
-              <a:rPr lang="en-US" sz="1300" b="1" dirty="0">
+              <a:rPr lang="en-US" sz="1550" b="1" dirty="0">
                 <a:solidFill>
                   <a:srgbClr val="4A5411"/>
                 </a:solidFill>
@@ -9686,7 +9842,7 @@
               <a:buNone/>
             </a:pPr>
             <a:r>
-              <a:rPr lang="en-US" sz="1000" dirty="0">
+              <a:rPr lang="en-US" sz="1200" dirty="0">
                 <a:solidFill>
                   <a:srgbClr val="6B7280"/>
                 </a:solidFill>
@@ -9726,6 +9882,10 @@
             <a:prstDash val="solid"/>
           </a:ln>
         </p:spPr>
+        <p:txBody>
+          <a:bodyPr/>
+          <a:p/>
+        </p:txBody>
       </p:sp>
       <p:sp>
         <p:nvSpPr>
@@ -9752,7 +9912,7 @@
               <a:buNone/>
             </a:pPr>
             <a:r>
-              <a:rPr lang="en-US" sz="1300" b="1" dirty="0">
+              <a:rPr lang="en-US" sz="1550" b="1" dirty="0">
                 <a:solidFill>
                   <a:srgbClr val="FFFFFF"/>
                 </a:solidFill>
@@ -9792,6 +9952,10 @@
             <a:prstDash val="solid"/>
           </a:ln>
         </p:spPr>
+        <p:txBody>
+          <a:bodyPr/>
+          <a:p/>
+        </p:txBody>
       </p:sp>
       <p:sp>
         <p:nvSpPr>
@@ -9818,7 +9982,7 @@
               <a:buNone/>
             </a:pPr>
             <a:r>
-              <a:rPr lang="en-US" sz="1300" b="1" dirty="0">
+              <a:rPr lang="en-US" sz="1550" b="1" dirty="0">
                 <a:solidFill>
                   <a:srgbClr val="4A5411"/>
                 </a:solidFill>
@@ -9858,6 +10022,10 @@
             <a:prstDash val="solid"/>
           </a:ln>
         </p:spPr>
+        <p:txBody>
+          <a:bodyPr/>
+          <a:p/>
+        </p:txBody>
       </p:sp>
       <p:sp>
         <p:nvSpPr>
@@ -9884,7 +10052,7 @@
               <a:buNone/>
             </a:pPr>
             <a:r>
-              <a:rPr lang="en-US" sz="1300" b="1" dirty="0">
+              <a:rPr lang="en-US" sz="1550" b="1" dirty="0">
                 <a:solidFill>
                   <a:srgbClr val="4A5411"/>
                 </a:solidFill>
@@ -9924,6 +10092,10 @@
             <a:prstDash val="solid"/>
           </a:ln>
         </p:spPr>
+        <p:txBody>
+          <a:bodyPr/>
+          <a:p/>
+        </p:txBody>
       </p:sp>
       <p:sp>
         <p:nvSpPr>
@@ -9950,7 +10122,7 @@
               <a:buNone/>
             </a:pPr>
             <a:r>
-              <a:rPr lang="en-US" sz="1300" b="1" dirty="0">
+              <a:rPr lang="en-US" sz="1550" b="1" dirty="0">
                 <a:solidFill>
                   <a:srgbClr val="FFFFFF"/>
                 </a:solidFill>
@@ -9990,6 +10162,10 @@
             <a:prstDash val="solid"/>
           </a:ln>
         </p:spPr>
+        <p:txBody>
+          <a:bodyPr/>
+          <a:p/>
+        </p:txBody>
       </p:sp>
       <p:sp>
         <p:nvSpPr>
@@ -10016,7 +10192,7 @@
               <a:buNone/>
             </a:pPr>
             <a:r>
-              <a:rPr lang="en-US" sz="1300" b="1" dirty="0">
+              <a:rPr lang="en-US" sz="1550" b="1" dirty="0">
                 <a:solidFill>
                   <a:srgbClr val="4A5411"/>
                 </a:solidFill>
@@ -10056,6 +10232,10 @@
             <a:prstDash val="solid"/>
           </a:ln>
         </p:spPr>
+        <p:txBody>
+          <a:bodyPr/>
+          <a:p/>
+        </p:txBody>
       </p:sp>
       <p:sp>
         <p:nvSpPr>
@@ -10082,7 +10262,7 @@
               <a:buNone/>
             </a:pPr>
             <a:r>
-              <a:rPr lang="en-US" sz="1300" b="1" dirty="0">
+              <a:rPr lang="en-US" sz="1550" b="1" dirty="0">
                 <a:solidFill>
                   <a:srgbClr val="FFFFFF"/>
                 </a:solidFill>
@@ -10121,7 +10301,7 @@
               <a:buNone/>
             </a:pPr>
             <a:r>
-              <a:rPr lang="en-US" sz="1000" dirty="0">
+              <a:rPr lang="en-US" sz="1200" dirty="0">
                 <a:solidFill>
                   <a:srgbClr val="6B7280"/>
                 </a:solidFill>
@@ -10160,7 +10340,7 @@
               <a:buNone/>
             </a:pPr>
             <a:r>
-              <a:rPr lang="en-US" sz="950" dirty="0">
+              <a:rPr lang="en-US" sz="1150" dirty="0">
                 <a:solidFill>
                   <a:srgbClr val="6B7280"/>
                 </a:solidFill>
@@ -10199,7 +10379,7 @@
               <a:buNone/>
             </a:pPr>
             <a:r>
-              <a:rPr lang="en-US" sz="950" dirty="0">
+              <a:rPr lang="en-US" sz="1150" dirty="0">
                 <a:solidFill>
                   <a:srgbClr val="6B7280"/>
                 </a:solidFill>
@@ -10238,7 +10418,7 @@
               <a:buNone/>
             </a:pPr>
             <a:r>
-              <a:rPr lang="en-US" sz="950" dirty="0">
+              <a:rPr lang="en-US" sz="1150" dirty="0">
                 <a:solidFill>
                   <a:srgbClr val="6B7280"/>
                 </a:solidFill>
@@ -10277,7 +10457,7 @@
               <a:buNone/>
             </a:pPr>
             <a:r>
-              <a:rPr lang="en-US" sz="950" dirty="0">
+              <a:rPr lang="en-US" sz="1150" dirty="0">
                 <a:solidFill>
                   <a:srgbClr val="6B7280"/>
                 </a:solidFill>
@@ -10316,7 +10496,7 @@
               <a:buNone/>
             </a:pPr>
             <a:r>
-              <a:rPr lang="en-US" sz="950" dirty="0">
+              <a:rPr lang="en-US" sz="1150" dirty="0">
                 <a:solidFill>
                   <a:srgbClr val="6B7280"/>
                 </a:solidFill>
@@ -10355,7 +10535,7 @@
               <a:buNone/>
             </a:pPr>
             <a:r>
-              <a:rPr lang="en-US" sz="950" dirty="0">
+              <a:rPr lang="en-US" sz="1150" dirty="0">
                 <a:solidFill>
                   <a:srgbClr val="6B7280"/>
                 </a:solidFill>
@@ -10393,6 +10573,10 @@
             <a:prstDash val="solid"/>
           </a:ln>
         </p:spPr>
+        <p:txBody>
+          <a:bodyPr/>
+          <a:p/>
+        </p:txBody>
       </p:sp>
       <p:sp>
         <p:nvSpPr>
@@ -10419,7 +10603,7 @@
               <a:buNone/>
             </a:pPr>
             <a:r>
-              <a:rPr lang="en-US" sz="1100" dirty="0">
+              <a:rPr lang="en-US" sz="1350" dirty="0">
                 <a:solidFill>
                   <a:srgbClr val="6B7280"/>
                 </a:solidFill>
@@ -10457,6 +10641,10 @@
             <a:prstDash val="solid"/>
           </a:ln>
         </p:spPr>
+        <p:txBody>
+          <a:bodyPr/>
+          <a:p/>
+        </p:txBody>
       </p:sp>
       <p:sp>
         <p:nvSpPr>
@@ -10483,7 +10671,7 @@
               <a:buNone/>
             </a:pPr>
             <a:r>
-              <a:rPr lang="en-US" sz="1100" dirty="0">
+              <a:rPr lang="en-US" sz="1350" dirty="0">
                 <a:solidFill>
                   <a:srgbClr val="6B7280"/>
                 </a:solidFill>
@@ -10525,7 +10713,7 @@
               <a:buNone/>
             </a:pPr>
             <a:r>
-              <a:rPr lang="en-US" sz="1200" dirty="0">
+              <a:rPr lang="en-US" sz="1450" dirty="0">
                 <a:solidFill>
                   <a:srgbClr val="6B7280"/>
                 </a:solidFill>
@@ -10533,7 +10721,7 @@
                 <a:ea typeface="Arial" pitchFamily="34" charset="-122"/>
                 <a:cs typeface="Arial" pitchFamily="34" charset="-120"/>
               </a:rPr>
-              <a:t>Every row and every column contains both conditions. A plate-position effect, a pipetting gradient, or a half-plate reagent failure now shows up as noise rather than as your result.</a:t>
+              <a:t>Every row and column contains both conditions. A plate gradient or half-plate failure now shows up as noise, not as your result.</a:t>
             </a:r>
             <a:endParaRPr lang="en-US" sz="1200" dirty="0"/>
           </a:p>
@@ -10565,6 +10753,10 @@
             <a:prstDash val="solid"/>
           </a:ln>
         </p:spPr>
+        <p:txBody>
+          <a:bodyPr/>
+          <a:p/>
+        </p:txBody>
       </p:sp>
       <p:sp>
         <p:nvSpPr>
@@ -10591,7 +10783,7 @@
               <a:buNone/>
             </a:pPr>
             <a:r>
-              <a:rPr lang="en-US" sz="1350" b="1" dirty="0">
+              <a:rPr lang="en-US" sz="1600" b="1" dirty="0">
                 <a:solidFill>
                   <a:srgbClr val="205081"/>
                 </a:solidFill>
@@ -10633,7 +10825,7 @@
               <a:buNone/>
             </a:pPr>
             <a:r>
-              <a:rPr lang="en-US" sz="1150" dirty="0">
+              <a:rPr lang="en-US" sz="1400" dirty="0">
                 <a:solidFill>
                   <a:srgbClr val="1F2933"/>
                 </a:solidFill>
@@ -10653,7 +10845,7 @@
               <a:buNone/>
             </a:pPr>
             <a:r>
-              <a:rPr lang="en-US" sz="1150" dirty="0">
+              <a:rPr lang="en-US" sz="1400" dirty="0">
                 <a:solidFill>
                   <a:srgbClr val="1F2933"/>
                 </a:solidFill>
@@ -10673,7 +10865,7 @@
               <a:buNone/>
             </a:pPr>
             <a:r>
-              <a:rPr lang="en-US" sz="1150" dirty="0">
+              <a:rPr lang="en-US" sz="1400" dirty="0">
                 <a:solidFill>
                   <a:srgbClr val="1F2933"/>
                 </a:solidFill>
@@ -10693,7 +10885,7 @@
               <a:buNone/>
             </a:pPr>
             <a:r>
-              <a:rPr lang="en-US" sz="1150" dirty="0">
+              <a:rPr lang="en-US" sz="1400" dirty="0">
                 <a:solidFill>
                   <a:srgbClr val="1F2933"/>
                 </a:solidFill>
@@ -10713,7 +10905,7 @@
               <a:buNone/>
             </a:pPr>
             <a:r>
-              <a:rPr lang="en-US" sz="1150" dirty="0">
+              <a:rPr lang="en-US" sz="1400" dirty="0">
                 <a:solidFill>
                   <a:srgbClr val="1F2933"/>
                 </a:solidFill>
@@ -10733,7 +10925,7 @@
               <a:buNone/>
             </a:pPr>
             <a:r>
-              <a:rPr lang="en-US" sz="1150" dirty="0">
+              <a:rPr lang="en-US" sz="1400" dirty="0">
                 <a:solidFill>
                   <a:srgbClr val="1F2933"/>
                 </a:solidFill>
@@ -10753,7 +10945,7 @@
               <a:buNone/>
             </a:pPr>
             <a:r>
-              <a:rPr lang="en-US" sz="1150" dirty="0">
+              <a:rPr lang="en-US" sz="1400" dirty="0">
                 <a:solidFill>
                   <a:srgbClr val="1F2933"/>
                 </a:solidFill>
@@ -10773,7 +10965,7 @@
               <a:buNone/>
             </a:pPr>
             <a:r>
-              <a:rPr lang="en-US" sz="1150" dirty="0">
+              <a:rPr lang="en-US" sz="1400" dirty="0">
                 <a:solidFill>
                   <a:srgbClr val="1F2933"/>
                 </a:solidFill>
@@ -10793,7 +10985,7 @@
               <a:buNone/>
             </a:pPr>
             <a:r>
-              <a:rPr lang="en-US" sz="1150" dirty="0">
+              <a:rPr lang="en-US" sz="1400" dirty="0">
                 <a:solidFill>
                   <a:srgbClr val="1F2933"/>
                 </a:solidFill>
@@ -10813,7 +11005,7 @@
               <a:buNone/>
             </a:pPr>
             <a:r>
-              <a:rPr lang="en-US" sz="1150" dirty="0">
+              <a:rPr lang="en-US" sz="1400" dirty="0">
                 <a:solidFill>
                   <a:srgbClr val="1F2933"/>
                 </a:solidFill>
@@ -10833,7 +11025,7 @@
               <a:buNone/>
             </a:pPr>
             <a:r>
-              <a:rPr lang="en-US" sz="1150" dirty="0">
+              <a:rPr lang="en-US" sz="1400" dirty="0">
                 <a:solidFill>
                   <a:srgbClr val="1F2933"/>
                 </a:solidFill>
@@ -10875,7 +11067,7 @@
               <a:buNone/>
             </a:pPr>
             <a:r>
-              <a:rPr lang="en-US" sz="1150" dirty="0">
+              <a:rPr lang="en-US" sz="1500" dirty="0">
                 <a:solidFill>
                   <a:srgbClr val="6B7280"/>
                 </a:solidFill>
@@ -10904,7 +11096,7 @@
               <a:buNone/>
             </a:pPr>
             <a:r>
-              <a:rPr lang="en-US" sz="1150" dirty="0">
+              <a:rPr lang="en-US" sz="1500" dirty="0">
                 <a:solidFill>
                   <a:srgbClr val="6B7280"/>
                 </a:solidFill>
@@ -10912,7 +11104,7 @@
                 <a:ea typeface="Arial" pitchFamily="34" charset="-122"/>
                 <a:cs typeface="Arial" pitchFamily="34" charset="-120"/>
               </a:rPr>
-              <a:t>Nine of the eleven cost you nothing but the discipline of writing them down while you still remember.</a:t>
+              <a:t>Nine cost nothing but the discipline of writing them down.</a:t>
             </a:r>
             <a:endParaRPr lang="en-US" sz="1150" dirty="0"/>
           </a:p>
@@ -10933,7 +11125,7 @@
               <a:buNone/>
             </a:pPr>
             <a:r>
-              <a:rPr lang="en-US" sz="1150" dirty="0">
+              <a:rPr lang="en-US" sz="1500" dirty="0">
                 <a:solidFill>
                   <a:srgbClr val="6B7280"/>
                 </a:solidFill>
@@ -10941,7 +11133,7 @@
                 <a:ea typeface="Arial" pitchFamily="34" charset="-122"/>
                 <a:cs typeface="Arial" pitchFamily="34" charset="-120"/>
               </a:rPr>
-              <a:t>Two of them — flowcell and lane — you can usually recover later from the FASTQ headers. Usually.</a:t>
+              <a:t>Flowcell and lane you can usually recover from the headers. Usually.</a:t>
             </a:r>
             <a:endParaRPr lang="en-US" sz="1150" dirty="0"/>
           </a:p>
@@ -10972,7 +11164,7 @@
               <a:buNone/>
             </a:pPr>
             <a:r>
-              <a:rPr lang="en-US" sz="1450" b="1" dirty="0">
+              <a:rPr lang="en-US" sz="1650" b="1" dirty="0">
                 <a:solidFill>
                   <a:srgbClr val="3172AE"/>
                 </a:solidFill>
@@ -11115,6 +11307,10 @@
             <a:prstDash val="solid"/>
           </a:ln>
         </p:spPr>
+        <p:txBody>
+          <a:bodyPr/>
+          <a:p/>
+        </p:txBody>
       </p:sp>
       <p:sp>
         <p:nvSpPr>
@@ -11141,7 +11337,7 @@
               <a:buNone/>
             </a:pPr>
             <a:r>
-              <a:rPr lang="en-US" sz="1150" dirty="0">
+              <a:rPr lang="en-US" sz="1400" dirty="0">
                 <a:solidFill>
                   <a:srgbClr val="FFC82C"/>
                 </a:solidFill>
@@ -11180,7 +11376,7 @@
               <a:buNone/>
             </a:pPr>
             <a:r>
-              <a:rPr lang="en-US" sz="1150" dirty="0">
+              <a:rPr lang="en-US" sz="1400" dirty="0">
                 <a:solidFill>
                   <a:srgbClr val="E8EDF2"/>
                 </a:solidFill>
@@ -11219,7 +11415,7 @@
               <a:buNone/>
             </a:pPr>
             <a:r>
-              <a:rPr lang="en-US" sz="1150" dirty="0">
+              <a:rPr lang="en-US" sz="1400" dirty="0">
                 <a:solidFill>
                   <a:srgbClr val="E8EDF2"/>
                 </a:solidFill>
@@ -11258,7 +11454,7 @@
               <a:buNone/>
             </a:pPr>
             <a:r>
-              <a:rPr lang="en-US" sz="1150" dirty="0">
+              <a:rPr lang="en-US" sz="1400" dirty="0">
                 <a:solidFill>
                   <a:srgbClr val="C0CD30"/>
                 </a:solidFill>
@@ -11297,7 +11493,7 @@
               <a:buNone/>
             </a:pPr>
             <a:r>
-              <a:rPr lang="en-US" sz="1150" b="1" dirty="0">
+              <a:rPr lang="en-US" sz="1400" b="1" dirty="0">
                 <a:solidFill>
                   <a:srgbClr val="6B7280"/>
                 </a:solidFill>
@@ -11336,7 +11532,7 @@
               <a:buNone/>
             </a:pPr>
             <a:r>
-              <a:rPr lang="en-US" sz="1150" dirty="0">
+              <a:rPr lang="en-US" sz="1400" dirty="0">
                 <a:solidFill>
                   <a:srgbClr val="1F2933"/>
                 </a:solidFill>
@@ -11375,7 +11571,7 @@
               <a:buNone/>
             </a:pPr>
             <a:r>
-              <a:rPr lang="en-US" sz="1150" b="1" dirty="0">
+              <a:rPr lang="en-US" sz="1400" b="1" dirty="0">
                 <a:solidFill>
                   <a:srgbClr val="6B7280"/>
                 </a:solidFill>
@@ -11414,7 +11610,7 @@
               <a:buNone/>
             </a:pPr>
             <a:r>
-              <a:rPr lang="en-US" sz="1150" dirty="0">
+              <a:rPr lang="en-US" sz="1400" dirty="0">
                 <a:solidFill>
                   <a:srgbClr val="1F2933"/>
                 </a:solidFill>
@@ -11453,7 +11649,7 @@
               <a:buNone/>
             </a:pPr>
             <a:r>
-              <a:rPr lang="en-US" sz="1150" b="1" dirty="0">
+              <a:rPr lang="en-US" sz="1400" b="1" dirty="0">
                 <a:solidFill>
                   <a:srgbClr val="6B7280"/>
                 </a:solidFill>
@@ -11492,7 +11688,7 @@
               <a:buNone/>
             </a:pPr>
             <a:r>
-              <a:rPr lang="en-US" sz="1150" dirty="0">
+              <a:rPr lang="en-US" sz="1400" dirty="0">
                 <a:solidFill>
                   <a:srgbClr val="1F2933"/>
                 </a:solidFill>
@@ -11531,7 +11727,7 @@
               <a:buNone/>
             </a:pPr>
             <a:r>
-              <a:rPr lang="en-US" sz="1150" b="1" dirty="0">
+              <a:rPr lang="en-US" sz="1400" b="1" dirty="0">
                 <a:solidFill>
                   <a:srgbClr val="6B7280"/>
                 </a:solidFill>
@@ -11570,7 +11766,7 @@
               <a:buNone/>
             </a:pPr>
             <a:r>
-              <a:rPr lang="en-US" sz="1150" dirty="0">
+              <a:rPr lang="en-US" sz="1400" dirty="0">
                 <a:solidFill>
                   <a:srgbClr val="1F2933"/>
                 </a:solidFill>
@@ -11610,6 +11806,10 @@
             <a:prstDash val="solid"/>
           </a:ln>
         </p:spPr>
+        <p:txBody>
+          <a:bodyPr/>
+          <a:p/>
+        </p:txBody>
       </p:sp>
       <p:sp>
         <p:nvSpPr>
@@ -11636,7 +11836,7 @@
               <a:buNone/>
             </a:pPr>
             <a:r>
-              <a:rPr lang="en-US" sz="1350" b="1" dirty="0">
+              <a:rPr lang="en-US" sz="1600" b="1" dirty="0">
                 <a:solidFill>
                   <a:srgbClr val="9C7A00"/>
                 </a:solidFill>
@@ -11678,7 +11878,7 @@
               <a:buNone/>
             </a:pPr>
             <a:r>
-              <a:rPr lang="en-US" sz="1100" dirty="0">
+              <a:rPr lang="en-US" sz="1550" dirty="0">
                 <a:solidFill>
                   <a:srgbClr val="1F2933"/>
                 </a:solidFill>
@@ -11707,7 +11907,7 @@
               <a:buNone/>
             </a:pPr>
             <a:r>
-              <a:rPr lang="en-US" sz="1100" dirty="0">
+              <a:rPr lang="en-US" sz="1550" dirty="0">
                 <a:solidFill>
                   <a:srgbClr val="1F2933"/>
                 </a:solidFill>
@@ -11715,7 +11915,7 @@
                 <a:ea typeface="Arial" pitchFamily="34" charset="-122"/>
                 <a:cs typeface="Arial" pitchFamily="34" charset="-120"/>
               </a:rPr>
-              <a:t>This is the field Gilad and Mizrahi-Man used to reconstruct the Mouse ENCODE batch structure from public data. Your batch variable may already be sitting in your files.</a:t>
+              <a:t>The field Gilad and Mizrahi-Man used to reconstruct the Mouse ENCODE batches. Your batch variable may already be in your files.</a:t>
             </a:r>
             <a:endParaRPr lang="en-US" sz="1100" dirty="0"/>
           </a:p>
@@ -11746,7 +11946,7 @@
               <a:buNone/>
             </a:pPr>
             <a:r>
-              <a:rPr lang="en-US" sz="1150" dirty="0">
+              <a:rPr lang="en-US" sz="1400" dirty="0">
                 <a:solidFill>
                   <a:srgbClr val="205081"/>
                 </a:solidFill>
@@ -11889,6 +12089,10 @@
             <a:prstDash val="solid"/>
           </a:ln>
         </p:spPr>
+        <p:txBody>
+          <a:bodyPr/>
+          <a:p/>
+        </p:txBody>
       </p:sp>
       <p:sp>
         <p:nvSpPr>
@@ -11954,7 +12158,7 @@
               <a:buNone/>
             </a:pPr>
             <a:r>
-              <a:rPr lang="en-US" sz="1150" dirty="0">
+              <a:rPr lang="en-US" sz="1400" dirty="0">
                 <a:solidFill>
                   <a:srgbClr val="6B7280"/>
                 </a:solidFill>
@@ -13610,6 +13814,10 @@
             <a:prstDash val="solid"/>
           </a:ln>
         </p:spPr>
+        <p:txBody>
+          <a:bodyPr/>
+          <a:p/>
+        </p:txBody>
       </p:sp>
       <p:sp>
         <p:nvSpPr>
@@ -13636,7 +13844,7 @@
               <a:buNone/>
             </a:pPr>
             <a:r>
-              <a:rPr lang="en-US" sz="1300" b="1" dirty="0">
+              <a:rPr lang="en-US" sz="1550" b="1" dirty="0">
                 <a:solidFill>
                   <a:srgbClr val="205081"/>
                 </a:solidFill>
@@ -13678,7 +13886,7 @@
               <a:buNone/>
             </a:pPr>
             <a:r>
-              <a:rPr lang="en-US" sz="1150" dirty="0">
+              <a:rPr lang="en-US" sz="1550" dirty="0">
                 <a:solidFill>
                   <a:srgbClr val="1F2933"/>
                 </a:solidFill>
@@ -13686,7 +13894,7 @@
                 <a:ea typeface="Arial" pitchFamily="34" charset="-122"/>
                 <a:cs typeface="Arial" pitchFamily="34" charset="-120"/>
               </a:rPr>
-              <a:t>The quality character is chr(Q + 33). So Q0 is “!”, Q37 is “F”, Q40 is “I”. The offset of 33 is why a modern Illumina quality line looks like a wall of F characters with the occasional comma.</a:t>
+              <a:t>The quality character is chr(Q + 33), so Q0 is “!”, Q37 is “F”, Q40 is “I”. That offset is why a modern quality line looks like a wall of F characters.</a:t>
             </a:r>
             <a:endParaRPr lang="en-US" sz="1150" dirty="0"/>
           </a:p>
@@ -13718,6 +13926,10 @@
             <a:prstDash val="solid"/>
           </a:ln>
         </p:spPr>
+        <p:txBody>
+          <a:bodyPr/>
+          <a:p/>
+        </p:txBody>
       </p:sp>
       <p:sp>
         <p:nvSpPr>
@@ -13744,7 +13956,7 @@
               <a:buNone/>
             </a:pPr>
             <a:r>
-              <a:rPr lang="en-US" sz="1300" b="1" dirty="0">
+              <a:rPr lang="en-US" sz="1550" b="1" dirty="0">
                 <a:solidFill>
                   <a:srgbClr val="3172AE"/>
                 </a:solidFill>
@@ -13786,7 +13998,7 @@
               <a:buNone/>
             </a:pPr>
             <a:r>
-              <a:rPr lang="en-US" sz="1200" dirty="0">
+              <a:rPr lang="en-US" sz="1350" dirty="0">
                 <a:solidFill>
                   <a:srgbClr val="1F2933"/>
                 </a:solidFill>
@@ -13806,7 +14018,7 @@
               <a:buNone/>
             </a:pPr>
             <a:r>
-              <a:rPr lang="en-US" sz="1200" dirty="0">
+              <a:rPr lang="en-US" sz="1350" dirty="0">
                 <a:solidFill>
                   <a:srgbClr val="1F2933"/>
                 </a:solidFill>
@@ -13814,7 +14026,7 @@
                 <a:ea typeface="Arial" pitchFamily="34" charset="-122"/>
                 <a:cs typeface="Arial" pitchFamily="34" charset="-120"/>
               </a:rPr>
-              <a:t>Across 400 million reads, that is 60 million incorrect bases in your file — from a run you would describe as excellent.</a:t>
+              <a:t>Across 400 million reads, that is 60 million incorrect bases — from a run you would call excellent.</a:t>
             </a:r>
             <a:endParaRPr lang="en-US" sz="1200" dirty="0"/>
           </a:p>
@@ -13848,7 +14060,7 @@
               <a:buNone/>
             </a:pPr>
             <a:r>
-              <a:rPr lang="en-US" sz="1150" dirty="0">
+              <a:rPr lang="en-US" sz="1550" dirty="0">
                 <a:solidFill>
                   <a:srgbClr val="6B7280"/>
                 </a:solidFill>
@@ -13856,7 +14068,7 @@
                 <a:ea typeface="Arial" pitchFamily="34" charset="-122"/>
                 <a:cs typeface="Arial" pitchFamily="34" charset="-120"/>
               </a:rPr>
-              <a:t>Depth is what rescues you: an error at one position in one read is outvoted. This is why coverage is a QC metric and not just a cost line.</a:t>
+              <a:t>Depth rescues you: an error at one position in one read is outvoted. Coverage is a QC metric, not just a cost line.</a:t>
             </a:r>
             <a:endParaRPr lang="en-US" sz="1150" dirty="0"/>
           </a:p>
@@ -13991,6 +14203,10 @@
             <a:prstDash val="solid"/>
           </a:ln>
         </p:spPr>
+        <p:txBody>
+          <a:bodyPr/>
+          <a:p/>
+        </p:txBody>
       </p:sp>
       <p:sp>
         <p:nvSpPr>
@@ -14017,7 +14233,7 @@
               <a:buNone/>
             </a:pPr>
             <a:r>
-              <a:rPr lang="en-US" sz="1450" b="1" dirty="0">
+              <a:rPr lang="en-US" sz="1650" b="1" dirty="0">
                 <a:solidFill>
                   <a:srgbClr val="2E7D32"/>
                 </a:solidFill>
@@ -14060,7 +14276,7 @@
               <a:buChar char="●"/>
             </a:pPr>
             <a:r>
-              <a:rPr lang="en-US" sz="1250" dirty="0">
+              <a:rPr lang="en-US" sz="1600" dirty="0">
                 <a:solidFill>
                   <a:srgbClr val="1F2933"/>
                 </a:solidFill>
@@ -14068,7 +14284,7 @@
                 <a:ea typeface="Arial" pitchFamily="34" charset="-122"/>
                 <a:cs typeface="Arial" pitchFamily="34" charset="-120"/>
               </a:rPr>
-              <a:t>Per-base quality collapsing part-way through the run</a:t>
+              <a:t>Quality collapsing part-way through the run</a:t>
             </a:r>
             <a:endParaRPr lang="en-US" sz="1250" dirty="0"/>
           </a:p>
@@ -14081,7 +14297,7 @@
               <a:buChar char="●"/>
             </a:pPr>
             <a:r>
-              <a:rPr lang="en-US" sz="1250" dirty="0">
+              <a:rPr lang="en-US" sz="1600" dirty="0">
                 <a:solidFill>
                   <a:srgbClr val="1F2933"/>
                 </a:solidFill>
@@ -14102,7 +14318,7 @@
               <a:buChar char="●"/>
             </a:pPr>
             <a:r>
-              <a:rPr lang="en-US" sz="1250" dirty="0">
+              <a:rPr lang="en-US" sz="1600" dirty="0">
                 <a:solidFill>
                   <a:srgbClr val="1F2933"/>
                 </a:solidFill>
@@ -14123,7 +14339,7 @@
               <a:buChar char="●"/>
             </a:pPr>
             <a:r>
-              <a:rPr lang="en-US" sz="1250" dirty="0">
+              <a:rPr lang="en-US" sz="1600" dirty="0">
                 <a:solidFill>
                   <a:srgbClr val="1F2933"/>
                 </a:solidFill>
@@ -14131,7 +14347,7 @@
                 <a:ea typeface="Arial" pitchFamily="34" charset="-122"/>
                 <a:cs typeface="Arial" pitchFamily="34" charset="-120"/>
               </a:rPr>
-              <a:t>One sample wildly different from its siblings</a:t>
+              <a:t>One sample unlike its siblings</a:t>
             </a:r>
             <a:endParaRPr lang="en-US" sz="1250" dirty="0"/>
           </a:p>
@@ -14144,28 +14360,7 @@
               <a:buChar char="●"/>
             </a:pPr>
             <a:r>
-              <a:rPr lang="en-US" sz="1250" dirty="0">
-                <a:solidFill>
-                  <a:srgbClr val="1F2933"/>
-                </a:solidFill>
-                <a:latin typeface="Arial" pitchFamily="34" charset="0"/>
-                <a:ea typeface="Arial" pitchFamily="34" charset="-122"/>
-                <a:cs typeface="Arial" pitchFamily="34" charset="-120"/>
-              </a:rPr>
-              <a:t>Overrepresented sequences you cannot identify</a:t>
-            </a:r>
-            <a:endParaRPr lang="en-US" sz="1250" dirty="0"/>
-          </a:p>
-          <a:p>
-            <a:pPr marL="177800" indent="-177800">
-              <a:spcAft>
-                <a:spcPts val="1200"/>
-              </a:spcAft>
-              <a:buSzPct val="100000"/>
-              <a:buChar char="●"/>
-            </a:pPr>
-            <a:r>
-              <a:rPr lang="en-US" sz="1250" dirty="0">
+              <a:rPr lang="en-US" sz="1600" dirty="0">
                 <a:solidFill>
                   <a:srgbClr val="1F2933"/>
                 </a:solidFill>
@@ -14205,6 +14400,10 @@
             <a:prstDash val="solid"/>
           </a:ln>
         </p:spPr>
+        <p:txBody>
+          <a:bodyPr/>
+          <a:p/>
+        </p:txBody>
       </p:sp>
       <p:sp>
         <p:nvSpPr>
@@ -14231,7 +14430,7 @@
               <a:buNone/>
             </a:pPr>
             <a:r>
-              <a:rPr lang="en-US" sz="1450" b="1" dirty="0">
+              <a:rPr lang="en-US" sz="1650" b="1" dirty="0">
                 <a:solidFill>
                   <a:srgbClr val="9C7A00"/>
                 </a:solidFill>
@@ -14274,7 +14473,7 @@
               <a:buChar char="●"/>
             </a:pPr>
             <a:r>
-              <a:rPr lang="en-US" sz="1250" dirty="0">
+              <a:rPr lang="en-US" sz="1600" dirty="0">
                 <a:solidFill>
                   <a:srgbClr val="1F2933"/>
                 </a:solidFill>
@@ -14282,7 +14481,7 @@
                 <a:ea typeface="Arial" pitchFamily="34" charset="-122"/>
                 <a:cs typeface="Arial" pitchFamily="34" charset="-120"/>
               </a:rPr>
-              <a:t>Per-base sequence content skew in the first ~12 bases — random hexamer priming in RNA-seq</a:t>
+              <a:t>Sequence content skew in the first ~12 bases — hexamer priming</a:t>
             </a:r>
             <a:endParaRPr lang="en-US" sz="1250" dirty="0"/>
           </a:p>
@@ -14295,7 +14494,7 @@
               <a:buChar char="●"/>
             </a:pPr>
             <a:r>
-              <a:rPr lang="en-US" sz="1250" dirty="0">
+              <a:rPr lang="en-US" sz="1600" dirty="0">
                 <a:solidFill>
                   <a:srgbClr val="1F2933"/>
                 </a:solidFill>
@@ -14303,7 +14502,7 @@
                 <a:ea typeface="Arial" pitchFamily="34" charset="-122"/>
                 <a:cs typeface="Arial" pitchFamily="34" charset="-120"/>
               </a:rPr>
-              <a:t>High duplication in amplicon, small-genome, or very deep libraries</a:t>
+              <a:t>High duplication in amplicon or very deep libraries</a:t>
             </a:r>
             <a:endParaRPr lang="en-US" sz="1250" dirty="0"/>
           </a:p>
@@ -14316,7 +14515,7 @@
               <a:buChar char="●"/>
             </a:pPr>
             <a:r>
-              <a:rPr lang="en-US" sz="1250" dirty="0">
+              <a:rPr lang="en-US" sz="1600" dirty="0">
                 <a:solidFill>
                   <a:srgbClr val="1F2933"/>
                 </a:solidFill>
@@ -14324,7 +14523,7 @@
                 <a:ea typeface="Arial" pitchFamily="34" charset="-122"/>
                 <a:cs typeface="Arial" pitchFamily="34" charset="-120"/>
               </a:rPr>
-              <a:t>GC warnings in metagenomics, where a mixed community has no single expected GC</a:t>
+              <a:t>GC warnings in metagenomics, with no single expected GC</a:t>
             </a:r>
             <a:endParaRPr lang="en-US" sz="1250" dirty="0"/>
           </a:p>
@@ -14337,7 +14536,7 @@
               <a:buChar char="●"/>
             </a:pPr>
             <a:r>
-              <a:rPr lang="en-US" sz="1250" dirty="0">
+              <a:rPr lang="en-US" sz="1600" dirty="0">
                 <a:solidFill>
                   <a:srgbClr val="1F2933"/>
                 </a:solidFill>
@@ -14345,7 +14544,7 @@
                 <a:ea typeface="Arial" pitchFamily="34" charset="-122"/>
                 <a:cs typeface="Arial" pitchFamily="34" charset="-120"/>
               </a:rPr>
-              <a:t>K-mer content flags in any enriched or targeted assay</a:t>
+              <a:t>K-mer flags in any enriched or targeted assay</a:t>
             </a:r>
             <a:endParaRPr lang="en-US" sz="1250" dirty="0"/>
           </a:p>
@@ -14377,6 +14576,10 @@
             <a:prstDash val="solid"/>
           </a:ln>
         </p:spPr>
+        <p:txBody>
+          <a:bodyPr/>
+          <a:p/>
+        </p:txBody>
       </p:sp>
       <p:sp>
         <p:nvSpPr>
@@ -14406,7 +14609,7 @@
               <a:buNone/>
             </a:pPr>
             <a:r>
-              <a:rPr lang="en-US" sz="1300" dirty="0">
+              <a:rPr lang="en-US" sz="1650" dirty="0">
                 <a:solidFill>
                   <a:srgbClr val="1F2933"/>
                 </a:solidFill>
@@ -14414,7 +14617,7 @@
                 <a:ea typeface="Arial" pitchFamily="34" charset="-122"/>
                 <a:cs typeface="Arial" pitchFamily="34" charset="-120"/>
               </a:rPr>
-              <a:t>FastQC does not know what experiment you ran. It compares your data to a generic expectation of a random shotgun library — so every enrichment, every amplification, and every protocol quirk you deliberately introduced shows up as a failure.</a:t>
+              <a:t>FastQC does not know what experiment you ran. It compares against a generic shotgun library, so every enrichment you deliberately introduced reads as a failure.</a:t>
             </a:r>
             <a:endParaRPr lang="en-US" sz="1300" dirty="0"/>
           </a:p>
@@ -14709,7 +14912,7 @@
               <a:buNone/>
             </a:pPr>
             <a:r>
-              <a:rPr lang="en-US" sz="1450" b="1" dirty="0">
+              <a:rPr lang="en-US" sz="1650" b="1" dirty="0">
                 <a:solidFill>
                   <a:srgbClr val="1F2933"/>
                 </a:solidFill>
@@ -14751,7 +14954,7 @@
               <a:buNone/>
             </a:pPr>
             <a:r>
-              <a:rPr lang="en-US" sz="1150" dirty="0">
+              <a:rPr lang="en-US" sz="1400" dirty="0">
                 <a:solidFill>
                   <a:srgbClr val="6B7280"/>
                 </a:solidFill>
@@ -14819,7 +15022,7 @@
               <a:buNone/>
             </a:pPr>
             <a:r>
-              <a:rPr lang="en-US" sz="1450" b="1" dirty="0">
+              <a:rPr lang="en-US" sz="1650" b="1" dirty="0">
                 <a:solidFill>
                   <a:srgbClr val="1F2933"/>
                 </a:solidFill>
@@ -14861,7 +15064,7 @@
               <a:buNone/>
             </a:pPr>
             <a:r>
-              <a:rPr lang="en-US" sz="1150" dirty="0">
+              <a:rPr lang="en-US" sz="1400" dirty="0">
                 <a:solidFill>
                   <a:srgbClr val="6B7280"/>
                 </a:solidFill>
@@ -14929,7 +15132,7 @@
               <a:buNone/>
             </a:pPr>
             <a:r>
-              <a:rPr lang="en-US" sz="1450" b="1" dirty="0">
+              <a:rPr lang="en-US" sz="1650" b="1" dirty="0">
                 <a:solidFill>
                   <a:srgbClr val="1F2933"/>
                 </a:solidFill>
@@ -14971,7 +15174,7 @@
               <a:buNone/>
             </a:pPr>
             <a:r>
-              <a:rPr lang="en-US" sz="1150" dirty="0">
+              <a:rPr lang="en-US" sz="1400" dirty="0">
                 <a:solidFill>
                   <a:srgbClr val="6B7280"/>
                 </a:solidFill>
@@ -15037,7 +15240,7 @@
               <a:buNone/>
             </a:pPr>
             <a:r>
-              <a:rPr lang="en-US" sz="1500" i="1" dirty="0">
+              <a:rPr lang="en-US" sz="1700" i="1" dirty="0">
                 <a:solidFill>
                   <a:srgbClr val="205081"/>
                 </a:solidFill>
@@ -15180,6 +15383,10 @@
             <a:prstDash val="solid"/>
           </a:ln>
         </p:spPr>
+        <p:txBody>
+          <a:bodyPr/>
+          <a:p/>
+        </p:txBody>
       </p:sp>
       <p:sp>
         <p:nvSpPr>
@@ -15205,6 +15412,10 @@
             <a:prstDash val="solid"/>
           </a:ln>
         </p:spPr>
+        <p:txBody>
+          <a:bodyPr/>
+          <a:p/>
+        </p:txBody>
       </p:sp>
       <p:sp>
         <p:nvSpPr>
@@ -15231,7 +15442,7 @@
               <a:buNone/>
             </a:pPr>
             <a:r>
-              <a:rPr lang="en-US" sz="1300" b="1" dirty="0">
+              <a:rPr lang="en-US" sz="1550" b="1" dirty="0">
                 <a:solidFill>
                   <a:srgbClr val="FFFFFF"/>
                 </a:solidFill>
@@ -15270,7 +15481,7 @@
               <a:buNone/>
             </a:pPr>
             <a:r>
-              <a:rPr lang="en-US" sz="1450" b="1" dirty="0">
+              <a:rPr lang="en-US" sz="1650" b="1" dirty="0">
                 <a:solidFill>
                   <a:srgbClr val="1F2933"/>
                 </a:solidFill>
@@ -15312,7 +15523,7 @@
               <a:buNone/>
             </a:pPr>
             <a:r>
-              <a:rPr lang="en-US" sz="1150" dirty="0">
+              <a:rPr lang="en-US" sz="1600" dirty="0">
                 <a:solidFill>
                   <a:srgbClr val="6B7280"/>
                 </a:solidFill>
@@ -15320,7 +15531,7 @@
                 <a:ea typeface="Arial" pitchFamily="34" charset="-122"/>
                 <a:cs typeface="Arial" pitchFamily="34" charset="-120"/>
               </a:rPr>
-              <a:t>Before any tool runs, know what one read means and what the denominator is. Counts are not abundances; enrichment is not depth.</a:t>
+              <a:t>Know what one read means and what the denominator is. Counts are not abundances.</a:t>
             </a:r>
             <a:endParaRPr lang="en-US" sz="1150" dirty="0"/>
           </a:p>
@@ -15352,6 +15563,10 @@
             <a:prstDash val="solid"/>
           </a:ln>
         </p:spPr>
+        <p:txBody>
+          <a:bodyPr/>
+          <a:p/>
+        </p:txBody>
       </p:sp>
       <p:sp>
         <p:nvSpPr>
@@ -15377,6 +15592,10 @@
             <a:prstDash val="solid"/>
           </a:ln>
         </p:spPr>
+        <p:txBody>
+          <a:bodyPr/>
+          <a:p/>
+        </p:txBody>
       </p:sp>
       <p:sp>
         <p:nvSpPr>
@@ -15403,7 +15622,7 @@
               <a:buNone/>
             </a:pPr>
             <a:r>
-              <a:rPr lang="en-US" sz="1300" b="1" dirty="0">
+              <a:rPr lang="en-US" sz="1550" b="1" dirty="0">
                 <a:solidFill>
                   <a:srgbClr val="FFFFFF"/>
                 </a:solidFill>
@@ -15442,7 +15661,7 @@
               <a:buNone/>
             </a:pPr>
             <a:r>
-              <a:rPr lang="en-US" sz="1450" b="1" dirty="0">
+              <a:rPr lang="en-US" sz="1650" b="1" dirty="0">
                 <a:solidFill>
                   <a:srgbClr val="1F2933"/>
                 </a:solidFill>
@@ -15484,7 +15703,7 @@
               <a:buNone/>
             </a:pPr>
             <a:r>
-              <a:rPr lang="en-US" sz="1150" dirty="0">
+              <a:rPr lang="en-US" sz="1600" dirty="0">
                 <a:solidFill>
                   <a:srgbClr val="6B7280"/>
                 </a:solidFill>
@@ -15492,7 +15711,7 @@
                 <a:ea typeface="Arial" pitchFamily="34" charset="-122"/>
                 <a:cs typeface="Arial" pitchFamily="34" charset="-120"/>
               </a:rPr>
-              <a:t>A substitution and an indel at the same Q score cause completely different downstream damage. Ask what it gets wrong, not how accurate it is.</a:t>
+              <a:t>A substitution and an indel at the same Q score do different damage. Ask what it gets wrong.</a:t>
             </a:r>
             <a:endParaRPr lang="en-US" sz="1150" dirty="0"/>
           </a:p>
@@ -15524,6 +15743,10 @@
             <a:prstDash val="solid"/>
           </a:ln>
         </p:spPr>
+        <p:txBody>
+          <a:bodyPr/>
+          <a:p/>
+        </p:txBody>
       </p:sp>
       <p:sp>
         <p:nvSpPr>
@@ -15549,6 +15772,10 @@
             <a:prstDash val="solid"/>
           </a:ln>
         </p:spPr>
+        <p:txBody>
+          <a:bodyPr/>
+          <a:p/>
+        </p:txBody>
       </p:sp>
       <p:sp>
         <p:nvSpPr>
@@ -15575,7 +15802,7 @@
               <a:buNone/>
             </a:pPr>
             <a:r>
-              <a:rPr lang="en-US" sz="1300" b="1" dirty="0">
+              <a:rPr lang="en-US" sz="1550" b="1" dirty="0">
                 <a:solidFill>
                   <a:srgbClr val="4A5411"/>
                 </a:solidFill>
@@ -15614,7 +15841,7 @@
               <a:buNone/>
             </a:pPr>
             <a:r>
-              <a:rPr lang="en-US" sz="1450" b="1" dirty="0">
+              <a:rPr lang="en-US" sz="1650" b="1" dirty="0">
                 <a:solidFill>
                   <a:srgbClr val="1F2933"/>
                 </a:solidFill>
@@ -15656,7 +15883,7 @@
               <a:buNone/>
             </a:pPr>
             <a:r>
-              <a:rPr lang="en-US" sz="1150" dirty="0">
+              <a:rPr lang="en-US" sz="1600" dirty="0">
                 <a:solidFill>
                   <a:srgbClr val="6B7280"/>
                 </a:solidFill>
@@ -15664,7 +15891,7 @@
                 <a:ea typeface="Arial" pitchFamily="34" charset="-122"/>
                 <a:cs typeface="Arial" pitchFamily="34" charset="-120"/>
               </a:rPr>
-              <a:t>For every level of your variable, you need samples from more than one batch. If you do not have that, say so — do not correct for it and hope.</a:t>
+              <a:t>For every level of your variable, you need more than one batch. If you do not have that, say so.</a:t>
             </a:r>
             <a:endParaRPr lang="en-US" sz="1150" dirty="0"/>
           </a:p>
@@ -15696,6 +15923,10 @@
             <a:prstDash val="solid"/>
           </a:ln>
         </p:spPr>
+        <p:txBody>
+          <a:bodyPr/>
+          <a:p/>
+        </p:txBody>
       </p:sp>
       <p:sp>
         <p:nvSpPr>
@@ -15722,7 +15953,7 @@
               <a:buNone/>
             </a:pPr>
             <a:r>
-              <a:rPr lang="en-US" sz="1500" b="1" dirty="0">
+              <a:rPr lang="en-US" sz="1700" b="1" dirty="0">
                 <a:solidFill>
                   <a:srgbClr val="3172AE"/>
                 </a:solidFill>
@@ -15800,6 +16031,10 @@
             <a:prstDash val="solid"/>
           </a:ln>
         </p:spPr>
+        <p:txBody>
+          <a:bodyPr/>
+          <a:p/>
+        </p:txBody>
       </p:sp>
       <p:sp>
         <p:nvSpPr>
@@ -15869,7 +16104,7 @@
               <a:buChar char="●"/>
             </a:pPr>
             <a:r>
-              <a:rPr lang="en-US" sz="1100" dirty="0">
+              <a:rPr lang="en-US" sz="1450" dirty="0">
                 <a:solidFill>
                   <a:srgbClr val="1F2933"/>
                 </a:solidFill>
@@ -15890,7 +16125,7 @@
               <a:buChar char="●"/>
             </a:pPr>
             <a:r>
-              <a:rPr lang="en-US" sz="1100" dirty="0">
+              <a:rPr lang="en-US" sz="1450" dirty="0">
                 <a:solidFill>
                   <a:srgbClr val="1F2933"/>
                 </a:solidFill>
@@ -15898,7 +16133,7 @@
                 <a:ea typeface="Arial" pitchFamily="34" charset="-122"/>
                 <a:cs typeface="Arial" pitchFamily="34" charset="-120"/>
               </a:rPr>
-              <a:t>What batches can you recover from the headers?</a:t>
+              <a:t>What batches can you recover?</a:t>
             </a:r>
             <a:endParaRPr lang="en-US" sz="1100" dirty="0"/>
           </a:p>
@@ -15911,7 +16146,7 @@
               <a:buChar char="●"/>
             </a:pPr>
             <a:r>
-              <a:rPr lang="en-US" sz="1100" dirty="0">
+              <a:rPr lang="en-US" sz="1450" dirty="0">
                 <a:solidFill>
                   <a:srgbClr val="1F2933"/>
                 </a:solidFill>
@@ -15932,7 +16167,7 @@
               <a:buChar char="●"/>
             </a:pPr>
             <a:r>
-              <a:rPr lang="en-US" sz="1100" dirty="0">
+              <a:rPr lang="en-US" sz="1450" dirty="0">
                 <a:solidFill>
                   <a:srgbClr val="1F2933"/>
                 </a:solidFill>
@@ -15940,7 +16175,7 @@
                 <a:ea typeface="Arial" pitchFamily="34" charset="-122"/>
                 <a:cs typeface="Arial" pitchFamily="34" charset="-120"/>
               </a:rPr>
-              <a:t>What could this design not have detected?</a:t>
+              <a:t>What could this design not detect?</a:t>
             </a:r>
             <a:endParaRPr lang="en-US" sz="1100" dirty="0"/>
           </a:p>
@@ -15971,7 +16206,7 @@
               <a:buNone/>
             </a:pPr>
             <a:r>
-              <a:rPr lang="en-US" sz="1300" i="1" dirty="0">
+              <a:rPr lang="en-US" sz="1550" i="1" dirty="0">
                 <a:solidFill>
                   <a:srgbClr val="6B7280"/>
                 </a:solidFill>
@@ -16114,6 +16349,10 @@
             <a:prstDash val="solid"/>
           </a:ln>
         </p:spPr>
+        <p:txBody>
+          <a:bodyPr/>
+          <a:p/>
+        </p:txBody>
       </p:sp>
       <p:sp>
         <p:nvSpPr>
@@ -16140,7 +16379,7 @@
               <a:buNone/>
             </a:pPr>
             <a:r>
-              <a:rPr lang="en-US" sz="1050" b="1" spc="120" kern="0" dirty="0">
+              <a:rPr lang="en-US" sz="1250" b="1" spc="120" kern="0" dirty="0">
                 <a:solidFill>
                   <a:srgbClr val="9AA5B1"/>
                 </a:solidFill>
@@ -16300,6 +16539,10 @@
             <a:prstDash val="solid"/>
           </a:ln>
         </p:spPr>
+        <p:txBody>
+          <a:bodyPr/>
+          <a:p/>
+        </p:txBody>
       </p:sp>
       <p:sp>
         <p:nvSpPr>
@@ -16326,7 +16569,7 @@
               <a:buNone/>
             </a:pPr>
             <a:r>
-              <a:rPr lang="en-US" sz="1050" b="1" spc="120" kern="0" dirty="0">
+              <a:rPr lang="en-US" sz="1250" b="1" spc="120" kern="0" dirty="0">
                 <a:solidFill>
                   <a:srgbClr val="3172AE"/>
                 </a:solidFill>
@@ -16486,6 +16729,10 @@
             <a:prstDash val="solid"/>
           </a:ln>
         </p:spPr>
+        <p:txBody>
+          <a:bodyPr/>
+          <a:p/>
+        </p:txBody>
       </p:sp>
       <p:sp>
         <p:nvSpPr>
@@ -16512,7 +16759,7 @@
               <a:buNone/>
             </a:pPr>
             <a:r>
-              <a:rPr lang="en-US" sz="1050" b="1" spc="120" kern="0" dirty="0">
+              <a:rPr lang="en-US" sz="1250" b="1" spc="120" kern="0" dirty="0">
                 <a:solidFill>
                   <a:srgbClr val="9AA5B1"/>
                 </a:solidFill>
@@ -16633,6 +16880,10 @@
             <a:prstDash val="solid"/>
           </a:ln>
         </p:spPr>
+        <p:txBody>
+          <a:bodyPr/>
+          <a:p/>
+        </p:txBody>
       </p:sp>
       <p:sp>
         <p:nvSpPr>
@@ -16662,7 +16913,7 @@
               <a:buNone/>
             </a:pPr>
             <a:r>
-              <a:rPr lang="en-US" sz="1600" b="1" dirty="0">
+              <a:rPr lang="en-US" sz="1800" b="1" dirty="0">
                 <a:solidFill>
                   <a:srgbClr val="1F2933"/>
                 </a:solidFill>
@@ -16670,7 +16921,7 @@
                 <a:ea typeface="Arial" pitchFamily="34" charset="-122"/>
                 <a:cs typeface="Arial" pitchFamily="34" charset="-120"/>
               </a:rPr>
-              <a:t>Step 1 and step 3 are nearly identical across assays. Step 2 is where they diverge — and step 2 is what you are actually analysing.</a:t>
+              <a:t>Steps 1 and 3 barely differ across assays. Step 2 is where they diverge, and step 2 is what you are analysing.</a:t>
             </a:r>
             <a:endParaRPr lang="en-US" sz="1600" dirty="0"/>
           </a:p>
@@ -16704,7 +16955,7 @@
               <a:buNone/>
             </a:pPr>
             <a:r>
-              <a:rPr lang="en-US" sz="1250" dirty="0">
+              <a:rPr lang="en-US" sz="1650" dirty="0">
                 <a:solidFill>
                   <a:srgbClr val="6B7280"/>
                 </a:solidFill>
@@ -16712,7 +16963,7 @@
                 <a:ea typeface="Arial" pitchFamily="34" charset="-122"/>
                 <a:cs typeface="Arial" pitchFamily="34" charset="-120"/>
               </a:rPr>
-              <a:t>A read is never raw biology. It is biology after a protocol did something to it. Most analysis mistakes are really misunderstandings of step 2 — what got enriched, what got amplified, what got thrown away.</a:t>
+              <a:t>A read is biology after a protocol acted on it. Most analysis mistakes are misunderstandings of step 2.</a:t>
             </a:r>
             <a:endParaRPr lang="en-US" sz="1250" dirty="0"/>
           </a:p>
@@ -16847,6 +17098,10 @@
             <a:prstDash val="solid"/>
           </a:ln>
         </p:spPr>
+        <p:txBody>
+          <a:bodyPr/>
+          <a:p/>
+        </p:txBody>
       </p:sp>
       <p:sp>
         <p:nvSpPr>
@@ -16872,6 +17127,10 @@
             <a:prstDash val="solid"/>
           </a:ln>
         </p:spPr>
+        <p:txBody>
+          <a:bodyPr/>
+          <a:p/>
+        </p:txBody>
       </p:sp>
       <p:sp>
         <p:nvSpPr>
@@ -16898,7 +17157,7 @@
               <a:buNone/>
             </a:pPr>
             <a:r>
-              <a:rPr lang="en-US" sz="1550" b="1" dirty="0">
+              <a:rPr lang="en-US" sz="1700" b="1" dirty="0">
                 <a:solidFill>
                   <a:srgbClr val="1F2933"/>
                 </a:solidFill>
@@ -16937,7 +17196,7 @@
               <a:buNone/>
             </a:pPr>
             <a:r>
-              <a:rPr lang="en-US" sz="1300" b="1" dirty="0">
+              <a:rPr lang="en-US" sz="1550" b="1" dirty="0">
                 <a:solidFill>
                   <a:srgbClr val="498BCA"/>
                 </a:solidFill>
@@ -16979,7 +17238,7 @@
               <a:buNone/>
             </a:pPr>
             <a:r>
-              <a:rPr lang="en-US" sz="1150" dirty="0">
+              <a:rPr lang="en-US" sz="1650" dirty="0">
                 <a:solidFill>
                   <a:srgbClr val="6B7280"/>
                 </a:solidFill>
@@ -16987,7 +17246,7 @@
                 <a:ea typeface="Arial" pitchFamily="34" charset="-122"/>
                 <a:cs typeface="Arial" pitchFamily="34" charset="-120"/>
               </a:rPr>
-              <a:t>A diploid genome has two copies of each locus. Depth at a site is interpretable on its own: 30× means 30 observations of a thing you know is there. This is why variant calling can be a per-site probability problem.</a:t>
+              <a:t>Two copies of each locus, so depth stands alone: 30× means 30 observations of something you know is there.</a:t>
             </a:r>
             <a:endParaRPr lang="en-US" sz="1150" dirty="0"/>
           </a:p>
@@ -17019,6 +17278,10 @@
             <a:prstDash val="solid"/>
           </a:ln>
         </p:spPr>
+        <p:txBody>
+          <a:bodyPr/>
+          <a:p/>
+        </p:txBody>
       </p:sp>
       <p:sp>
         <p:nvSpPr>
@@ -17044,6 +17307,10 @@
             <a:prstDash val="solid"/>
           </a:ln>
         </p:spPr>
+        <p:txBody>
+          <a:bodyPr/>
+          <a:p/>
+        </p:txBody>
       </p:sp>
       <p:sp>
         <p:nvSpPr>
@@ -17070,7 +17337,7 @@
               <a:buNone/>
             </a:pPr>
             <a:r>
-              <a:rPr lang="en-US" sz="1550" b="1" dirty="0">
+              <a:rPr lang="en-US" sz="1700" b="1" dirty="0">
                 <a:solidFill>
                   <a:srgbClr val="1F2933"/>
                 </a:solidFill>
@@ -17109,7 +17376,7 @@
               <a:buNone/>
             </a:pPr>
             <a:r>
-              <a:rPr lang="en-US" sz="1300" b="1" dirty="0">
+              <a:rPr lang="en-US" sz="1550" b="1" dirty="0">
                 <a:solidFill>
                   <a:srgbClr val="B8860B"/>
                 </a:solidFill>
@@ -17151,7 +17418,7 @@
               <a:buNone/>
             </a:pPr>
             <a:r>
-              <a:rPr lang="en-US" sz="1150" dirty="0">
+              <a:rPr lang="en-US" sz="1600" dirty="0">
                 <a:solidFill>
                   <a:srgbClr val="6B7280"/>
                 </a:solidFill>
@@ -17159,7 +17426,7 @@
                 <a:ea typeface="Arial" pitchFamily="34" charset="-122"/>
                 <a:cs typeface="Arial" pitchFamily="34" charset="-120"/>
               </a:rPr>
-              <a:t>Library size is set by how much you loaded, not by biology. A gene's raw count means nothing until it is normalised. If one gene doubles, every other gene's fraction falls — without changing.</a:t>
+              <a:t>Library size is what you loaded, not biology. A raw count means nothing until normalised. If one gene doubles, every other fraction falls.</a:t>
             </a:r>
             <a:endParaRPr lang="en-US" sz="1150" dirty="0"/>
           </a:p>
@@ -17191,6 +17458,10 @@
             <a:prstDash val="solid"/>
           </a:ln>
         </p:spPr>
+        <p:txBody>
+          <a:bodyPr/>
+          <a:p/>
+        </p:txBody>
       </p:sp>
       <p:sp>
         <p:nvSpPr>
@@ -17216,6 +17487,10 @@
             <a:prstDash val="solid"/>
           </a:ln>
         </p:spPr>
+        <p:txBody>
+          <a:bodyPr/>
+          <a:p/>
+        </p:txBody>
       </p:sp>
       <p:sp>
         <p:nvSpPr>
@@ -17242,7 +17517,7 @@
               <a:buNone/>
             </a:pPr>
             <a:r>
-              <a:rPr lang="en-US" sz="1550" b="1" dirty="0">
+              <a:rPr lang="en-US" sz="1700" b="1" dirty="0">
                 <a:solidFill>
                   <a:srgbClr val="1F2933"/>
                 </a:solidFill>
@@ -17281,7 +17556,7 @@
               <a:buNone/>
             </a:pPr>
             <a:r>
-              <a:rPr lang="en-US" sz="1300" b="1" dirty="0">
+              <a:rPr lang="en-US" sz="1550" b="1" dirty="0">
                 <a:solidFill>
                   <a:srgbClr val="7C8A1E"/>
                 </a:solidFill>
@@ -17323,7 +17598,7 @@
               <a:buNone/>
             </a:pPr>
             <a:r>
-              <a:rPr lang="en-US" sz="1150" dirty="0">
+              <a:rPr lang="en-US" sz="1600" dirty="0">
                 <a:solidFill>
                   <a:srgbClr val="6B7280"/>
                 </a:solidFill>
@@ -17331,7 +17606,7 @@
                 <a:ea typeface="Arial" pitchFamily="34" charset="-122"/>
                 <a:cs typeface="Arial" pitchFamily="34" charset="-120"/>
               </a:rPr>
-              <a:t>Enrichment is meaningless without a model of what unenriched looks like. That is why peak callers need an input control or a local background estimate, and why FRiP is a real QC metric.</a:t>
+              <a:t>Enrichment is meaningless without knowing what unenriched looks like. Hence input controls, and FRiP as a QC metric.</a:t>
             </a:r>
             <a:endParaRPr lang="en-US" sz="1150" dirty="0"/>
           </a:p>
@@ -17363,6 +17638,10 @@
             <a:prstDash val="solid"/>
           </a:ln>
         </p:spPr>
+        <p:txBody>
+          <a:bodyPr/>
+          <a:p/>
+        </p:txBody>
       </p:sp>
       <p:sp>
         <p:nvSpPr>
@@ -17388,6 +17667,10 @@
             <a:prstDash val="solid"/>
           </a:ln>
         </p:spPr>
+        <p:txBody>
+          <a:bodyPr/>
+          <a:p/>
+        </p:txBody>
       </p:sp>
       <p:sp>
         <p:nvSpPr>
@@ -17414,7 +17697,7 @@
               <a:buNone/>
             </a:pPr>
             <a:r>
-              <a:rPr lang="en-US" sz="1550" b="1" dirty="0">
+              <a:rPr lang="en-US" sz="1700" b="1" dirty="0">
                 <a:solidFill>
                   <a:srgbClr val="1F2933"/>
                 </a:solidFill>
@@ -17453,7 +17736,7 @@
               <a:buNone/>
             </a:pPr>
             <a:r>
-              <a:rPr lang="en-US" sz="1300" b="1" dirty="0">
+              <a:rPr lang="en-US" sz="1550" b="1" dirty="0">
                 <a:solidFill>
                   <a:srgbClr val="205081"/>
                 </a:solidFill>
@@ -17495,7 +17778,7 @@
               <a:buNone/>
             </a:pPr>
             <a:r>
-              <a:rPr lang="en-US" sz="1150" dirty="0">
+              <a:rPr lang="en-US" sz="1600" dirty="0">
                 <a:solidFill>
                   <a:srgbClr val="6B7280"/>
                 </a:solidFill>
@@ -17503,7 +17786,7 @@
                 <a:ea typeface="Arial" pitchFamily="34" charset="-122"/>
                 <a:cs typeface="Arial" pitchFamily="34" charset="-120"/>
               </a:rPr>
-              <a:t>Composition problems and unknown-organism problems at the same time. This is why Week 10 spends a session on why standard statistics mislead on compositional data.</a:t>
+              <a:t>Composition and unknown organisms at once. Week 10 spends a session on why standard statistics mislead here.</a:t>
             </a:r>
             <a:endParaRPr lang="en-US" sz="1150" dirty="0"/>
           </a:p>
@@ -17638,6 +17921,10 @@
             <a:prstDash val="solid"/>
           </a:ln>
         </p:spPr>
+        <p:txBody>
+          <a:bodyPr/>
+          <a:p/>
+        </p:txBody>
       </p:sp>
       <p:sp>
         <p:nvSpPr>
@@ -17664,7 +17951,7 @@
               <a:buNone/>
             </a:pPr>
             <a:r>
-              <a:rPr lang="en-US" sz="1600" b="1" dirty="0">
+              <a:rPr lang="en-US" sz="1750" b="1" dirty="0">
                 <a:solidFill>
                   <a:srgbClr val="3172AE"/>
                 </a:solidFill>
@@ -17706,7 +17993,7 @@
               <a:buNone/>
             </a:pPr>
             <a:r>
-              <a:rPr lang="en-US" sz="1250" dirty="0">
+              <a:rPr lang="en-US" sz="1600" dirty="0">
                 <a:solidFill>
                   <a:srgbClr val="1F2933"/>
                 </a:solidFill>
@@ -17714,7 +18001,7 @@
                 <a:ea typeface="Arial" pitchFamily="34" charset="-122"/>
                 <a:cs typeface="Arial" pitchFamily="34" charset="-120"/>
               </a:rPr>
-              <a:t>Illumina reads millions of identical copies in a cluster, one base per cycle, all at once. The signal is an average over the cluster, which is why it is clean.</a:t>
+              <a:t>Illumina reads millions of identical copies in a cluster, one base per cycle. The signal is an average over the cluster, which is why it is clean.</a:t>
             </a:r>
             <a:endParaRPr lang="en-US" sz="1250" dirty="0"/>
           </a:p>
@@ -17748,7 +18035,7 @@
               <a:buNone/>
             </a:pPr>
             <a:r>
-              <a:rPr lang="en-US" sz="1250" dirty="0">
+              <a:rPr lang="en-US" sz="1600" dirty="0">
                 <a:solidFill>
                   <a:srgbClr val="6B7280"/>
                 </a:solidFill>
@@ -17756,7 +18043,7 @@
                 <a:ea typeface="Arial" pitchFamily="34" charset="-122"/>
                 <a:cs typeface="Arial" pitchFamily="34" charset="-120"/>
               </a:rPr>
-              <a:t>The cost: molecules drift out of step. A few per cycle fall behind or run ahead, and the error compounds. That is the ceiling on read length — not optics, not cost.</a:t>
+              <a:t>Molecules drift out of step and the error compounds. That is the ceiling on read length — not optics, not cost.</a:t>
             </a:r>
             <a:endParaRPr lang="en-US" sz="1250" dirty="0"/>
           </a:p>
@@ -17788,6 +18075,10 @@
             <a:prstDash val="solid"/>
           </a:ln>
         </p:spPr>
+        <p:txBody>
+          <a:bodyPr/>
+          <a:p/>
+        </p:txBody>
       </p:sp>
       <p:sp>
         <p:nvSpPr>
@@ -17814,7 +18105,7 @@
               <a:buNone/>
             </a:pPr>
             <a:r>
-              <a:rPr lang="en-US" sz="1600" b="1" dirty="0">
+              <a:rPr lang="en-US" sz="1750" b="1" dirty="0">
                 <a:solidFill>
                   <a:srgbClr val="205081"/>
                 </a:solidFill>
@@ -17856,7 +18147,7 @@
               <a:buNone/>
             </a:pPr>
             <a:r>
-              <a:rPr lang="en-US" sz="1250" dirty="0">
+              <a:rPr lang="en-US" sz="1500" dirty="0">
                 <a:solidFill>
                   <a:srgbClr val="1F2933"/>
                 </a:solidFill>
@@ -17898,7 +18189,7 @@
               <a:buNone/>
             </a:pPr>
             <a:r>
-              <a:rPr lang="en-US" sz="1250" dirty="0">
+              <a:rPr lang="en-US" sz="1600" dirty="0">
                 <a:solidFill>
                   <a:srgbClr val="6B7280"/>
                 </a:solidFill>
@@ -17906,7 +18197,7 @@
                 <a:ea typeface="Arial" pitchFamily="34" charset="-122"/>
                 <a:cs typeface="Arial" pitchFamily="34" charset="-120"/>
               </a:rPr>
-              <a:t>The cost: there is no cluster to average over. A single molecule gives a noisy signal, so accuracy has to be recovered — by repeated passes, or by a better basecaller.</a:t>
+              <a:t>No cluster to average over. A single molecule is noisy, so accuracy is recovered by repeated passes or a better basecaller.</a:t>
             </a:r>
             <a:endParaRPr lang="en-US" sz="1250" dirty="0"/>
           </a:p>
@@ -17934,6 +18225,10 @@
             <a:prstDash val="solid"/>
           </a:ln>
         </p:spPr>
+        <p:txBody>
+          <a:bodyPr/>
+          <a:p/>
+        </p:txBody>
       </p:sp>
       <p:sp>
         <p:nvSpPr>
@@ -17960,7 +18255,7 @@
               <a:buNone/>
             </a:pPr>
             <a:r>
-              <a:rPr lang="en-US" sz="1500" b="1" dirty="0">
+              <a:rPr lang="en-US" sz="1650" b="1" dirty="0">
                 <a:solidFill>
                   <a:srgbClr val="1F2933"/>
                 </a:solidFill>
@@ -17968,7 +18263,7 @@
                 <a:ea typeface="Arial" pitchFamily="34" charset="-122"/>
                 <a:cs typeface="Arial" pitchFamily="34" charset="-120"/>
               </a:rPr>
-              <a:t>Read length is not a marketing number. It follows directly from whether your chemistry has to keep millions of molecules in lockstep.</a:t>
+              <a:t>Read length follows from whether your chemistry keeps molecules in lockstep.</a:t>
             </a:r>
             <a:endParaRPr lang="en-US" sz="1500" dirty="0"/>
           </a:p>
@@ -17999,7 +18294,7 @@
               <a:buNone/>
             </a:pPr>
             <a:r>
-              <a:rPr lang="en-US" sz="1250" dirty="0">
+              <a:rPr lang="en-US" sz="1400" dirty="0">
                 <a:solidFill>
                   <a:srgbClr val="6B7280"/>
                 </a:solidFill>
@@ -18007,7 +18302,7 @@
                 <a:ea typeface="Arial" pitchFamily="34" charset="-122"/>
                 <a:cs typeface="Arial" pitchFamily="34" charset="-120"/>
               </a:rPr>
-              <a:t>Everything else on the next four slides — accuracy, cost, error mode, what each platform is good for — comes out of this one difference.</a:t>
+              <a:t>Accuracy, cost and error mode all follow from that one difference.</a:t>
             </a:r>
             <a:endParaRPr lang="en-US" sz="1250" dirty="0"/>
           </a:p>
@@ -18145,7 +18440,7 @@
               <a:buChar char="●"/>
             </a:pPr>
             <a:r>
-              <a:rPr lang="en-US" sz="1350" dirty="0">
+              <a:rPr lang="en-US" sz="1600" dirty="0">
                 <a:solidFill>
                   <a:srgbClr val="1F2933"/>
                 </a:solidFill>
@@ -18153,7 +18448,7 @@
                 <a:ea typeface="Arial" pitchFamily="34" charset="-122"/>
                 <a:cs typeface="Arial" pitchFamily="34" charset="-120"/>
               </a:rPr>
-              <a:t>Paired-end, 2 × 50 to 2 × 150 bp. Longer kits exist; almost nobody uses them for genomics.</a:t>
+              <a:t>Paired-end, 2 × 50 to 2 × 150 bp.</a:t>
             </a:r>
             <a:endParaRPr lang="en-US" sz="1350" dirty="0"/>
           </a:p>
@@ -18166,7 +18461,7 @@
               <a:buChar char="●"/>
             </a:pPr>
             <a:r>
-              <a:rPr lang="en-US" sz="1350" dirty="0">
+              <a:rPr lang="en-US" sz="1600" dirty="0">
                 <a:solidFill>
                   <a:srgbClr val="1F2933"/>
                 </a:solidFill>
@@ -18174,7 +18469,7 @@
                 <a:ea typeface="Arial" pitchFamily="34" charset="-122"/>
                 <a:cs typeface="Arial" pitchFamily="34" charset="-120"/>
               </a:rPr>
-              <a:t>NovaSeq X Plus: up to ~16 Tb and tens of billions of reads per dual flow-cell run.</a:t>
+              <a:t>NovaSeq X Plus: ~16 Tb per dual flow-cell run.</a:t>
             </a:r>
             <a:endParaRPr lang="en-US" sz="1350" dirty="0"/>
           </a:p>
@@ -18187,7 +18482,7 @@
               <a:buChar char="●"/>
             </a:pPr>
             <a:r>
-              <a:rPr lang="en-US" sz="1350" dirty="0">
+              <a:rPr lang="en-US" sz="1600" dirty="0">
                 <a:solidFill>
                   <a:srgbClr val="1F2933"/>
                 </a:solidFill>
@@ -18195,7 +18490,7 @@
                 <a:ea typeface="Arial" pitchFamily="34" charset="-122"/>
                 <a:cs typeface="Arial" pitchFamily="34" charset="-120"/>
               </a:rPr>
-              <a:t>Specification is ≥85% of bases above Q30; well-behaved runs report well above that.</a:t>
+              <a:t>≥85% of bases above Q30.</a:t>
             </a:r>
             <a:endParaRPr lang="en-US" sz="1350" dirty="0"/>
           </a:p>
@@ -18208,7 +18503,7 @@
               <a:buChar char="●"/>
             </a:pPr>
             <a:r>
-              <a:rPr lang="en-US" sz="1350" dirty="0">
+              <a:rPr lang="en-US" sz="1600" dirty="0">
                 <a:solidFill>
                   <a:srgbClr val="1F2933"/>
                 </a:solidFill>
@@ -18216,7 +18511,7 @@
                 <a:ea typeface="Arial" pitchFamily="34" charset="-122"/>
                 <a:cs typeface="Arial" pitchFamily="34" charset="-120"/>
               </a:rPr>
-              <a:t>Dominant error is substitution — one base called as another.</a:t>
+              <a:t>Dominant error is substitution.</a:t>
             </a:r>
             <a:endParaRPr lang="en-US" sz="1350" dirty="0"/>
           </a:p>
@@ -18229,7 +18524,7 @@
               <a:buChar char="●"/>
             </a:pPr>
             <a:r>
-              <a:rPr lang="en-US" sz="1350" dirty="0">
+              <a:rPr lang="en-US" sz="1600" dirty="0">
                 <a:solidFill>
                   <a:srgbClr val="1F2933"/>
                 </a:solidFill>
@@ -18237,7 +18532,7 @@
                 <a:ea typeface="Arial" pitchFamily="34" charset="-122"/>
                 <a:cs typeface="Arial" pitchFamily="34" charset="-120"/>
               </a:rPr>
-              <a:t>Quality declines along the read. That decline is dephasing, not bad DNA.</a:t>
+              <a:t>Quality declines along the read — dephasing, not bad DNA.</a:t>
             </a:r>
             <a:endParaRPr lang="en-US" sz="1350" dirty="0"/>
           </a:p>
@@ -18285,6 +18580,10 @@
             <a:prstDash val="solid"/>
           </a:ln>
         </p:spPr>
+        <p:txBody>
+          <a:bodyPr/>
+          <a:p/>
+        </p:txBody>
       </p:sp>
       <p:sp>
         <p:nvSpPr>
@@ -18311,7 +18610,7 @@
               <a:buNone/>
             </a:pPr>
             <a:r>
-              <a:rPr lang="en-US" sz="1300" b="1" dirty="0">
+              <a:rPr lang="en-US" sz="1550" b="1" dirty="0">
                 <a:solidFill>
                   <a:srgbClr val="3172AE"/>
                 </a:solidFill>
@@ -18353,7 +18652,7 @@
               <a:buNone/>
             </a:pPr>
             <a:r>
-              <a:rPr lang="en-US" sz="1250" dirty="0">
+              <a:rPr lang="en-US" sz="1600" dirty="0">
                 <a:solidFill>
                   <a:srgbClr val="1F2933"/>
                 </a:solidFill>
@@ -18361,7 +18660,7 @@
                 <a:ea typeface="Arial" pitchFamily="34" charset="-122"/>
                 <a:cs typeface="Arial" pitchFamily="34" charset="-120"/>
               </a:rPr>
-              <a:t>If you need 30× coverage of a human genome, or 30 million reads across 24 RNA-seq samples, this is the cheapest way to get it by a wide margin. If you need to span a 5 kb repeat, no amount of depth will help you.</a:t>
+              <a:t>For 30× of a human genome, or 30 million reads across 24 samples, this is the cheapest route by far. To span a 5 kb repeat, no depth helps.</a:t>
             </a:r>
             <a:endParaRPr lang="en-US" sz="1250" dirty="0"/>
           </a:p>
@@ -18392,7 +18691,7 @@
               <a:buNone/>
             </a:pPr>
             <a:r>
-              <a:rPr lang="en-US" sz="950" i="1" dirty="0">
+              <a:rPr lang="en-US" sz="1250" i="1" dirty="0">
                 <a:solidFill>
                   <a:srgbClr val="9AA5B1"/>
                 </a:solidFill>
@@ -18400,7 +18699,7 @@
                 <a:ea typeface="Arial" pitchFamily="34" charset="-122"/>
                 <a:cs typeface="Arial" pitchFamily="34" charset="-120"/>
               </a:rPr>
-              <a:t>Illustrative curve showing the expected shape; your own run's numbers come from FastQC in Session 2. Instrument figures: Illumina NovaSeq X specifications, 2026.</a:t>
+              <a:t>Illustrative curve. Your own numbers come from FastQC in Session 2. Instrument figures: Illumina NovaSeq X, 2026.</a:t>
             </a:r>
             <a:endParaRPr lang="en-US" sz="950" dirty="0"/>
           </a:p>
@@ -18535,6 +18834,10 @@
             <a:prstDash val="solid"/>
           </a:ln>
         </p:spPr>
+        <p:txBody>
+          <a:bodyPr/>
+          <a:p/>
+        </p:txBody>
       </p:sp>
       <p:sp>
         <p:nvSpPr>
@@ -18561,7 +18864,7 @@
               <a:buNone/>
             </a:pPr>
             <a:r>
-              <a:rPr lang="en-US" sz="1500" b="1" dirty="0">
+              <a:rPr lang="en-US" sz="1700" b="1" dirty="0">
                 <a:solidFill>
                   <a:srgbClr val="205081"/>
                 </a:solidFill>
@@ -18603,7 +18906,7 @@
               <a:buNone/>
             </a:pPr>
             <a:r>
-              <a:rPr lang="en-US" sz="1250" dirty="0">
+              <a:rPr lang="en-US" sz="1650" dirty="0">
                 <a:solidFill>
                   <a:srgbClr val="1F2933"/>
                 </a:solidFill>
@@ -18611,7 +18914,7 @@
                 <a:ea typeface="Arial" pitchFamily="34" charset="-122"/>
                 <a:cs typeface="Arial" pitchFamily="34" charset="-120"/>
               </a:rPr>
-              <a:t>The library molecule is circularised. One polymerase reads around it again and again. Each individual pass is mediocre; the consensus across passes is excellent.</a:t>
+              <a:t>The molecule is circularised and read around repeatedly. Each pass is mediocre; the consensus is excellent.</a:t>
             </a:r>
             <a:endParaRPr lang="en-US" sz="1250" dirty="0"/>
           </a:p>
@@ -18645,7 +18948,7 @@
               <a:buNone/>
             </a:pPr>
             <a:r>
-              <a:rPr lang="en-US" sz="1250" dirty="0">
+              <a:rPr lang="en-US" sz="1650" dirty="0">
                 <a:solidFill>
                   <a:srgbClr val="6B7280"/>
                 </a:solidFill>
@@ -18653,7 +18956,7 @@
                 <a:ea typeface="Arial" pitchFamily="34" charset="-122"/>
                 <a:cs typeface="Arial" pitchFamily="34" charset="-120"/>
               </a:rPr>
-              <a:t>A HiFi read is therefore not a raw observation — it is already a consensus, computed on the instrument before you ever see it.</a:t>
+              <a:t>A HiFi read is already a consensus, computed on the instrument before you see it.</a:t>
             </a:r>
             <a:endParaRPr lang="en-US" sz="1250" dirty="0"/>
           </a:p>
@@ -18685,6 +18988,10 @@
             <a:prstDash val="solid"/>
           </a:ln>
         </p:spPr>
+        <p:txBody>
+          <a:bodyPr/>
+          <a:p/>
+        </p:txBody>
       </p:sp>
       <p:sp>
         <p:nvSpPr>
@@ -18753,7 +19060,7 @@
               <a:buNone/>
             </a:pPr>
             <a:r>
-              <a:rPr lang="en-US" sz="1050" dirty="0">
+              <a:rPr lang="en-US" sz="1250" dirty="0">
                 <a:solidFill>
                   <a:srgbClr val="6B7280"/>
                 </a:solidFill>
@@ -18793,6 +19100,10 @@
             <a:prstDash val="solid"/>
           </a:ln>
         </p:spPr>
+        <p:txBody>
+          <a:bodyPr/>
+          <a:p/>
+        </p:txBody>
       </p:sp>
       <p:sp>
         <p:nvSpPr>
@@ -18861,7 +19172,7 @@
               <a:buNone/>
             </a:pPr>
             <a:r>
-              <a:rPr lang="en-US" sz="1050" dirty="0">
+              <a:rPr lang="en-US" sz="1250" dirty="0">
                 <a:solidFill>
                   <a:srgbClr val="6B7280"/>
                 </a:solidFill>
@@ -18901,6 +19212,10 @@
             <a:prstDash val="solid"/>
           </a:ln>
         </p:spPr>
+        <p:txBody>
+          <a:bodyPr/>
+          <a:p/>
+        </p:txBody>
       </p:sp>
       <p:sp>
         <p:nvSpPr>
@@ -18969,7 +19284,7 @@
               <a:buNone/>
             </a:pPr>
             <a:r>
-              <a:rPr lang="en-US" sz="1050" dirty="0">
+              <a:rPr lang="en-US" sz="1250" dirty="0">
                 <a:solidFill>
                   <a:srgbClr val="6B7280"/>
                 </a:solidFill>
@@ -19009,6 +19324,10 @@
             <a:prstDash val="solid"/>
           </a:ln>
         </p:spPr>
+        <p:txBody>
+          <a:bodyPr/>
+          <a:p/>
+        </p:txBody>
       </p:sp>
       <p:sp>
         <p:nvSpPr>
@@ -19074,7 +19393,7 @@
               <a:buNone/>
             </a:pPr>
             <a:r>
-              <a:rPr lang="en-US" sz="1050" dirty="0">
+              <a:rPr lang="en-US" sz="1250" dirty="0">
                 <a:solidFill>
                   <a:srgbClr val="6B7280"/>
                 </a:solidFill>
@@ -19114,6 +19433,10 @@
             <a:prstDash val="solid"/>
           </a:ln>
         </p:spPr>
+        <p:txBody>
+          <a:bodyPr/>
+          <a:p/>
+        </p:txBody>
       </p:sp>
       <p:sp>
         <p:nvSpPr>
@@ -19140,7 +19463,7 @@
               <a:buNone/>
             </a:pPr>
             <a:r>
-              <a:rPr lang="en-US" sz="1300" b="1" dirty="0">
+              <a:rPr lang="en-US" sz="1550" b="1" dirty="0">
                 <a:solidFill>
                   <a:srgbClr val="9C7A00"/>
                 </a:solidFill>
@@ -19182,7 +19505,7 @@
               <a:buNone/>
             </a:pPr>
             <a:r>
-              <a:rPr lang="en-US" sz="1250" dirty="0">
+              <a:rPr lang="en-US" sz="1600" dirty="0">
                 <a:solidFill>
                   <a:srgbClr val="1F2933"/>
                 </a:solidFill>
@@ -19190,7 +19513,7 @@
                 <a:ea typeface="Arial" pitchFamily="34" charset="-122"/>
                 <a:cs typeface="Arial" pitchFamily="34" charset="-120"/>
               </a:rPr>
-              <a:t>Passes and insert length compete for the same fixed run time. A long insert gets fewer passes, and below the pass threshold it is simply excluded from the HiFi output. Asking for 40 kb inserts does not give you 40 kb HiFi reads — it gives you fewer reads.</a:t>
+              <a:t>Passes and insert length compete for the same run time. Long inserts get fewer passes, and below threshold they are dropped. Asking for 40 kb inserts gives you fewer reads, not longer ones.</a:t>
             </a:r>
             <a:endParaRPr lang="en-US" sz="1250" dirty="0"/>
           </a:p>
@@ -19221,7 +19544,7 @@
               <a:buNone/>
             </a:pPr>
             <a:r>
-              <a:rPr lang="en-US" sz="950" i="1" dirty="0">
+              <a:rPr lang="en-US" sz="1250" i="1" dirty="0">
                 <a:solidFill>
                   <a:srgbClr val="9AA5B1"/>
                 </a:solidFill>
@@ -19229,7 +19552,7 @@
                 <a:ea typeface="Arial" pitchFamily="34" charset="-122"/>
                 <a:cs typeface="Arial" pitchFamily="34" charset="-120"/>
               </a:rPr>
-              <a:t>Figures from PacBio Revio documentation and sequencing-core specifications, 2026. Yields depend on chemistry version and sample quality.</a:t>
+              <a:t>PacBio Revio documentation and core specifications, 2026. Yields depend on chemistry version and sample quality.</a:t>
             </a:r>
             <a:endParaRPr lang="en-US" sz="950" dirty="0"/>
           </a:p>
@@ -19364,6 +19687,10 @@
             <a:prstDash val="solid"/>
           </a:ln>
         </p:spPr>
+        <p:txBody>
+          <a:bodyPr/>
+          <a:p/>
+        </p:txBody>
       </p:sp>
       <p:sp>
         <p:nvSpPr>
@@ -19389,6 +19716,10 @@
             <a:prstDash val="solid"/>
           </a:ln>
         </p:spPr>
+        <p:txBody>
+          <a:bodyPr/>
+          <a:p/>
+        </p:txBody>
       </p:sp>
       <p:sp>
         <p:nvSpPr>
@@ -19415,7 +19746,7 @@
               <a:buNone/>
             </a:pPr>
             <a:r>
-              <a:rPr lang="en-US" sz="1300" b="1" dirty="0">
+              <a:rPr lang="en-US" sz="1550" b="1" dirty="0">
                 <a:solidFill>
                   <a:srgbClr val="1F2933"/>
                 </a:solidFill>
@@ -19457,7 +19788,7 @@
               <a:buNone/>
             </a:pPr>
             <a:r>
-              <a:rPr lang="en-US" sz="1100" dirty="0">
+              <a:rPr lang="en-US" sz="1350" dirty="0">
                 <a:solidFill>
                   <a:srgbClr val="6B7280"/>
                 </a:solidFill>
@@ -19497,6 +19828,10 @@
             <a:prstDash val="solid"/>
           </a:ln>
         </p:spPr>
+        <p:txBody>
+          <a:bodyPr/>
+          <a:p/>
+        </p:txBody>
       </p:sp>
       <p:sp>
         <p:nvSpPr>
@@ -19522,6 +19857,10 @@
             <a:prstDash val="solid"/>
           </a:ln>
         </p:spPr>
+        <p:txBody>
+          <a:bodyPr/>
+          <a:p/>
+        </p:txBody>
       </p:sp>
       <p:sp>
         <p:nvSpPr>
@@ -19548,7 +19887,7 @@
               <a:buNone/>
             </a:pPr>
             <a:r>
-              <a:rPr lang="en-US" sz="1300" b="1" dirty="0">
+              <a:rPr lang="en-US" sz="1550" b="1" dirty="0">
                 <a:solidFill>
                   <a:srgbClr val="1F2933"/>
                 </a:solidFill>
@@ -19590,7 +19929,7 @@
               <a:buNone/>
             </a:pPr>
             <a:r>
-              <a:rPr lang="en-US" sz="1100" dirty="0">
+              <a:rPr lang="en-US" sz="1350" dirty="0">
                 <a:solidFill>
                   <a:srgbClr val="6B7280"/>
                 </a:solidFill>
@@ -19630,6 +19969,10 @@
             <a:prstDash val="solid"/>
           </a:ln>
         </p:spPr>
+        <p:txBody>
+          <a:bodyPr/>
+          <a:p/>
+        </p:txBody>
       </p:sp>
       <p:sp>
         <p:nvSpPr>
@@ -19655,6 +19998,10 @@
             <a:prstDash val="solid"/>
           </a:ln>
         </p:spPr>
+        <p:txBody>
+          <a:bodyPr/>
+          <a:p/>
+        </p:txBody>
       </p:sp>
       <p:sp>
         <p:nvSpPr>
@@ -19681,7 +20028,7 @@
               <a:buNone/>
             </a:pPr>
             <a:r>
-              <a:rPr lang="en-US" sz="1300" b="1" dirty="0">
+              <a:rPr lang="en-US" sz="1550" b="1" dirty="0">
                 <a:solidFill>
                   <a:srgbClr val="1F2933"/>
                 </a:solidFill>
@@ -19723,7 +20070,7 @@
               <a:buNone/>
             </a:pPr>
             <a:r>
-              <a:rPr lang="en-US" sz="1100" dirty="0">
+              <a:rPr lang="en-US" sz="1350" dirty="0">
                 <a:solidFill>
                   <a:srgbClr val="6B7280"/>
                 </a:solidFill>
@@ -19763,6 +20110,10 @@
             <a:prstDash val="solid"/>
           </a:ln>
         </p:spPr>
+        <p:txBody>
+          <a:bodyPr/>
+          <a:p/>
+        </p:txBody>
       </p:sp>
       <p:sp>
         <p:nvSpPr>
@@ -19788,6 +20139,10 @@
             <a:prstDash val="solid"/>
           </a:ln>
         </p:spPr>
+        <p:txBody>
+          <a:bodyPr/>
+          <a:p/>
+        </p:txBody>
       </p:sp>
       <p:sp>
         <p:nvSpPr>
@@ -19814,7 +20169,7 @@
               <a:buNone/>
             </a:pPr>
             <a:r>
-              <a:rPr lang="en-US" sz="1300" b="1" dirty="0">
+              <a:rPr lang="en-US" sz="1550" b="1" dirty="0">
                 <a:solidFill>
                   <a:srgbClr val="1F2933"/>
                 </a:solidFill>
@@ -19856,7 +20211,7 @@
               <a:buNone/>
             </a:pPr>
             <a:r>
-              <a:rPr lang="en-US" sz="1100" dirty="0">
+              <a:rPr lang="en-US" sz="1350" dirty="0">
                 <a:solidFill>
                   <a:srgbClr val="6B7280"/>
                 </a:solidFill>
@@ -19896,6 +20251,10 @@
             <a:prstDash val="solid"/>
           </a:ln>
         </p:spPr>
+        <p:txBody>
+          <a:bodyPr/>
+          <a:p/>
+        </p:txBody>
       </p:sp>
       <p:sp>
         <p:nvSpPr>
@@ -19922,7 +20281,7 @@
               <a:buNone/>
             </a:pPr>
             <a:r>
-              <a:rPr lang="en-US" sz="1450" b="1" dirty="0">
+              <a:rPr lang="en-US" sz="1650" b="1" dirty="0">
                 <a:solidFill>
                   <a:srgbClr val="205081"/>
                 </a:solidFill>
@@ -19965,7 +20324,7 @@
               <a:buChar char="●"/>
             </a:pPr>
             <a:r>
-              <a:rPr lang="en-US" sz="1150" dirty="0">
+              <a:rPr lang="en-US" sz="1550" dirty="0">
                 <a:solidFill>
                   <a:srgbClr val="1F2933"/>
                 </a:solidFill>
@@ -19973,7 +20332,7 @@
                 <a:ea typeface="Arial" pitchFamily="34" charset="-122"/>
                 <a:cs typeface="Arial" pitchFamily="34" charset="-120"/>
               </a:rPr>
-              <a:t>R10.4.1 flow cells with Kit 14: simplex reads around 99% and above with super-accuracy models.</a:t>
+              <a:t>R10.4.1 with Kit 14: simplex ~99%+ with sup models.</a:t>
             </a:r>
             <a:endParaRPr lang="en-US" sz="1150" dirty="0"/>
           </a:p>
@@ -19986,7 +20345,7 @@
               <a:buChar char="●"/>
             </a:pPr>
             <a:r>
-              <a:rPr lang="en-US" sz="1150" dirty="0">
+              <a:rPr lang="en-US" sz="1550" dirty="0">
                 <a:solidFill>
                   <a:srgbClr val="1F2933"/>
                 </a:solidFill>
@@ -19994,7 +20353,7 @@
                 <a:ea typeface="Arial" pitchFamily="34" charset="-122"/>
                 <a:cs typeface="Arial" pitchFamily="34" charset="-120"/>
               </a:rPr>
-              <a:t>Duplex reads reach roughly Q30, but are a minority of any run.</a:t>
+              <a:t>Duplex reaches ~Q30, a minority of any run.</a:t>
             </a:r>
             <a:endParaRPr lang="en-US" sz="1150" dirty="0"/>
           </a:p>
@@ -20007,7 +20366,7 @@
               <a:buChar char="●"/>
             </a:pPr>
             <a:r>
-              <a:rPr lang="en-US" sz="1150" dirty="0">
+              <a:rPr lang="en-US" sz="1550" dirty="0">
                 <a:solidFill>
                   <a:srgbClr val="1F2933"/>
                 </a:solidFill>
@@ -20015,7 +20374,7 @@
                 <a:ea typeface="Arial" pitchFamily="34" charset="-122"/>
                 <a:cs typeface="Arial" pitchFamily="34" charset="-120"/>
               </a:rPr>
-              <a:t>Over 100 Gb per PromethION flow cell is routine.</a:t>
+              <a:t>Over 100 Gb per PromethION flow cell.</a:t>
             </a:r>
             <a:endParaRPr lang="en-US" sz="1150" dirty="0"/>
           </a:p>
@@ -20028,7 +20387,7 @@
               <a:buChar char="●"/>
             </a:pPr>
             <a:r>
-              <a:rPr lang="en-US" sz="1150" dirty="0">
+              <a:rPr lang="en-US" sz="1550" dirty="0">
                 <a:solidFill>
                   <a:srgbClr val="1F2933"/>
                 </a:solidFill>
@@ -20036,28 +20395,7 @@
                 <a:ea typeface="Arial" pitchFamily="34" charset="-122"/>
                 <a:cs typeface="Arial" pitchFamily="34" charset="-120"/>
               </a:rPr>
-              <a:t>Read length is set by your extraction: ultra-long protocols reach hundreds of kb.</a:t>
-            </a:r>
-            <a:endParaRPr lang="en-US" sz="1150" dirty="0"/>
-          </a:p>
-          <a:p>
-            <a:pPr marL="177800" indent="-177800">
-              <a:spcAft>
-                <a:spcPts val="900"/>
-              </a:spcAft>
-              <a:buSzPct val="100000"/>
-              <a:buChar char="●"/>
-            </a:pPr>
-            <a:r>
-              <a:rPr lang="en-US" sz="1150" dirty="0">
-                <a:solidFill>
-                  <a:srgbClr val="1F2933"/>
-                </a:solidFill>
-                <a:latin typeface="Arial" pitchFamily="34" charset="0"/>
-                <a:ea typeface="Arial" pitchFamily="34" charset="-122"/>
-                <a:cs typeface="Arial" pitchFamily="34" charset="-120"/>
-              </a:rPr>
-              <a:t>Native DNA and RNA, so base modifications come free — no bisulfite.</a:t>
+              <a:t>Read length is set by your extraction; modifications come free.</a:t>
             </a:r>
             <a:endParaRPr lang="en-US" sz="1150" dirty="0"/>
           </a:p>
@@ -20089,6 +20427,10 @@
             <a:prstDash val="solid"/>
           </a:ln>
         </p:spPr>
+        <p:txBody>
+          <a:bodyPr/>
+          <a:p/>
+        </p:txBody>
       </p:sp>
       <p:sp>
         <p:nvSpPr>
@@ -20118,7 +20460,7 @@
               <a:buNone/>
             </a:pPr>
             <a:r>
-              <a:rPr lang="en-US" sz="1300" b="1" dirty="0">
+              <a:rPr lang="en-US" sz="1650" b="1" dirty="0">
                 <a:solidFill>
                   <a:srgbClr val="3172AE"/>
                 </a:solidFill>
@@ -20126,7 +20468,7 @@
                 <a:ea typeface="Arial" pitchFamily="34" charset="-122"/>
                 <a:cs typeface="Arial" pitchFamily="34" charset="-120"/>
               </a:rPr>
-              <a:t>Record your basecaller and model version in your methods. It is not a detail — re-basecalling old signal with a newer model is a routine way to improve a dataset without touching the bench.</a:t>
+              <a:t>Record your basecaller and model version. Re-basecalling old signal with a newer model improves a dataset without touching the bench.</a:t>
             </a:r>
             <a:endParaRPr lang="en-US" sz="1300" dirty="0"/>
           </a:p>
@@ -20157,7 +20499,7 @@
               <a:buNone/>
             </a:pPr>
             <a:r>
-              <a:rPr lang="en-US" sz="950" i="1" dirty="0">
+              <a:rPr lang="en-US" sz="1150" i="1" dirty="0">
                 <a:solidFill>
                   <a:srgbClr val="9AA5B1"/>
                 </a:solidFill>
@@ -20300,6 +20642,10 @@
             <a:prstDash val="solid"/>
           </a:ln>
         </p:spPr>
+        <p:txBody>
+          <a:bodyPr/>
+          <a:p/>
+        </p:txBody>
       </p:sp>
       <p:sp>
         <p:nvSpPr>
@@ -20326,7 +20672,7 @@
               <a:buNone/>
             </a:pPr>
             <a:r>
-              <a:rPr lang="en-US" sz="1500" b="1" dirty="0">
+              <a:rPr lang="en-US" sz="1700" b="1" dirty="0">
                 <a:solidFill>
                   <a:srgbClr val="3172AE"/>
                 </a:solidFill>
@@ -20368,7 +20714,7 @@
               <a:buNone/>
             </a:pPr>
             <a:r>
-              <a:rPr lang="en-US" sz="1300" dirty="0">
+              <a:rPr lang="en-US" sz="1550" dirty="0">
                 <a:solidFill>
                   <a:srgbClr val="1F2933"/>
                 </a:solidFill>
@@ -20388,7 +20734,7 @@
               <a:buNone/>
             </a:pPr>
             <a:r>
-              <a:rPr lang="en-US" sz="1300" dirty="0">
+              <a:rPr lang="en-US" sz="1550" dirty="0">
                 <a:solidFill>
                   <a:srgbClr val="1F2933"/>
                 </a:solidFill>
@@ -20430,7 +20776,7 @@
               <a:buNone/>
             </a:pPr>
             <a:r>
-              <a:rPr lang="en-US" sz="1200" dirty="0">
+              <a:rPr lang="en-US" sz="1400" dirty="0">
                 <a:solidFill>
                   <a:srgbClr val="6B7280"/>
                 </a:solidFill>
@@ -20438,7 +20784,7 @@
                 <a:ea typeface="Arial" pitchFamily="34" charset="-122"/>
                 <a:cs typeface="Arial" pitchFamily="34" charset="-120"/>
               </a:rPr>
-              <a:t>Looks like a variant. You have decades of tooling for exactly this: depth, allele balance, strand bias, base quality. A false positive is detectable and filterable.</a:t>
+              <a:t>Looks like a variant. Decades of tooling handle this: depth, allele balance, strand bias. Detectable and filterable.</a:t>
             </a:r>
             <a:endParaRPr lang="en-US" sz="1200" dirty="0"/>
           </a:p>
@@ -20470,6 +20816,10 @@
             <a:prstDash val="solid"/>
           </a:ln>
         </p:spPr>
+        <p:txBody>
+          <a:bodyPr/>
+          <a:p/>
+        </p:txBody>
       </p:sp>
       <p:sp>
         <p:nvSpPr>
@@ -20496,7 +20846,7 @@
               <a:buNone/>
             </a:pPr>
             <a:r>
-              <a:rPr lang="en-US" sz="1500" b="1" dirty="0">
+              <a:rPr lang="en-US" sz="1700" b="1" dirty="0">
                 <a:solidFill>
                   <a:srgbClr val="9C7A00"/>
                 </a:solidFill>
@@ -20538,7 +20888,7 @@
               <a:buNone/>
             </a:pPr>
             <a:r>
-              <a:rPr lang="en-US" sz="1300" dirty="0">
+              <a:rPr lang="en-US" sz="1550" dirty="0">
                 <a:solidFill>
                   <a:srgbClr val="1F2933"/>
                 </a:solidFill>
@@ -20558,7 +20908,7 @@
               <a:buNone/>
             </a:pPr>
             <a:r>
-              <a:rPr lang="en-US" sz="1300" dirty="0">
+              <a:rPr lang="en-US" sz="1550" dirty="0">
                 <a:solidFill>
                   <a:srgbClr val="1F2933"/>
                 </a:solidFill>
@@ -20600,7 +20950,7 @@
               <a:buNone/>
             </a:pPr>
             <a:r>
-              <a:rPr lang="en-US" sz="1200" dirty="0">
+              <a:rPr lang="en-US" sz="1400" dirty="0">
                 <a:solidFill>
                   <a:srgbClr val="6B7280"/>
                 </a:solidFill>
@@ -20608,7 +20958,7 @@
                 <a:ea typeface="Arial" pitchFamily="34" charset="-122"/>
                 <a:cs typeface="Arial" pitchFamily="34" charset="-120"/>
               </a:rPr>
-              <a:t>In a coding region that is a frameshift. Everything downstream of it is wrong protein, and gene prediction will happily annotate a truncated ORF with no warning at all.</a:t>
+              <a:t>In a coding region that is a frameshift. Everything downstream is wrong protein, and annotation will not warn you.</a:t>
             </a:r>
             <a:endParaRPr lang="en-US" sz="1200" dirty="0"/>
           </a:p>
@@ -20640,6 +20990,10 @@
             <a:prstDash val="solid"/>
           </a:ln>
         </p:spPr>
+        <p:txBody>
+          <a:bodyPr/>
+          <a:p/>
+        </p:txBody>
       </p:sp>
       <p:sp>
         <p:nvSpPr>
@@ -20666,7 +21020,7 @@
               <a:buNone/>
             </a:pPr>
             <a:r>
-              <a:rPr lang="en-US" sz="1550" b="1" dirty="0">
+              <a:rPr lang="en-US" sz="1700" b="1" dirty="0">
                 <a:solidFill>
                   <a:srgbClr val="1F2933"/>
                 </a:solidFill>
@@ -20708,7 +21062,7 @@
               <a:buNone/>
             </a:pPr>
             <a:r>
-              <a:rPr lang="en-US" sz="1250" dirty="0">
+              <a:rPr lang="en-US" sz="1600" dirty="0">
                 <a:solidFill>
                   <a:srgbClr val="6B7280"/>
                 </a:solidFill>
@@ -20716,7 +21070,7 @@
                 <a:ea typeface="Arial" pitchFamily="34" charset="-122"/>
                 <a:cs typeface="Arial" pitchFamily="34" charset="-120"/>
               </a:rPr>
-              <a:t>This is why long-read bacterial assemblies were polished with Illumina data for years, and why the honest question about a platform is never “how accurate is it” but “what does it get wrong, and does my analysis care?”</a:t>
+              <a:t>This is why long-read assemblies were polished with Illumina for years. The honest question is never “how accurate” but “what does it get wrong, and does my analysis care?”</a:t>
             </a:r>
             <a:endParaRPr lang="en-US" sz="1250" dirty="0"/>
           </a:p>

</xml_diff>